<commit_message>
Improve variable-K SLS diagnostics
</commit_message>
<xml_diff>
--- a/outputs/dyadic_sls_poc_progress.pptx
+++ b/outputs/dyadic_sls_poc_progress.pptx
@@ -2,23 +2,23 @@
 <file path=ppt/presentation.xml><?xml version="1.0" encoding="utf-8"?>
 <p:presentation xmlns:p="http://schemas.openxmlformats.org/presentationml/2006/main">
   <p:sldMasterIdLst>
-    <p:sldMasterId xmlns:r="http://schemas.openxmlformats.org/officeDocument/2006/relationships" id="2147483648" r:id="Rbf8e704c648449a3"/>
+    <p:sldMasterId xmlns:r="http://schemas.openxmlformats.org/officeDocument/2006/relationships" id="2147483648" r:id="R86253850080e453c"/>
   </p:sldMasterIdLst>
   <p:notesMasterIdLst>
-    <p:notesMasterId xmlns:r="http://schemas.openxmlformats.org/officeDocument/2006/relationships" r:id="R5a422855a5ca46e6"/>
+    <p:notesMasterId xmlns:r="http://schemas.openxmlformats.org/officeDocument/2006/relationships" r:id="R7ec92d2868074ae3"/>
   </p:notesMasterIdLst>
   <p:sldIdLst>
-    <p:sldId xmlns:r="http://schemas.openxmlformats.org/officeDocument/2006/relationships" id="256" r:id="R79748013409a4c4e"/>
-    <p:sldId xmlns:r="http://schemas.openxmlformats.org/officeDocument/2006/relationships" id="257" r:id="Rc80b5c26fa3c49af"/>
-    <p:sldId xmlns:r="http://schemas.openxmlformats.org/officeDocument/2006/relationships" id="258" r:id="R572c233d25cd40e1"/>
-    <p:sldId xmlns:r="http://schemas.openxmlformats.org/officeDocument/2006/relationships" id="259" r:id="R7346c33bd1064736"/>
-    <p:sldId xmlns:r="http://schemas.openxmlformats.org/officeDocument/2006/relationships" id="260" r:id="Rbd7daef53d664c1d"/>
-    <p:sldId xmlns:r="http://schemas.openxmlformats.org/officeDocument/2006/relationships" id="261" r:id="R46c426dda0c744a9"/>
-    <p:sldId xmlns:r="http://schemas.openxmlformats.org/officeDocument/2006/relationships" id="262" r:id="R8f19455b27f048b1"/>
-    <p:sldId xmlns:r="http://schemas.openxmlformats.org/officeDocument/2006/relationships" id="263" r:id="R20a1f16cca5e415f"/>
-    <p:sldId xmlns:r="http://schemas.openxmlformats.org/officeDocument/2006/relationships" id="264" r:id="Rbf681a1ac6c84843"/>
-    <p:sldId xmlns:r="http://schemas.openxmlformats.org/officeDocument/2006/relationships" id="265" r:id="R9b2037861f8242b9"/>
-    <p:sldId xmlns:r="http://schemas.openxmlformats.org/officeDocument/2006/relationships" id="266" r:id="Ra02eb91118874d53"/>
+    <p:sldId xmlns:r="http://schemas.openxmlformats.org/officeDocument/2006/relationships" id="256" r:id="R375ff1589eba4f2d"/>
+    <p:sldId xmlns:r="http://schemas.openxmlformats.org/officeDocument/2006/relationships" id="257" r:id="R74ed7a68e303487d"/>
+    <p:sldId xmlns:r="http://schemas.openxmlformats.org/officeDocument/2006/relationships" id="258" r:id="Rba8e32bb81d740b9"/>
+    <p:sldId xmlns:r="http://schemas.openxmlformats.org/officeDocument/2006/relationships" id="259" r:id="R83983bf475844dbf"/>
+    <p:sldId xmlns:r="http://schemas.openxmlformats.org/officeDocument/2006/relationships" id="260" r:id="Rc8a40196a2514fda"/>
+    <p:sldId xmlns:r="http://schemas.openxmlformats.org/officeDocument/2006/relationships" id="261" r:id="R6c142c2796ff4a97"/>
+    <p:sldId xmlns:r="http://schemas.openxmlformats.org/officeDocument/2006/relationships" id="262" r:id="R308d32a81258434e"/>
+    <p:sldId xmlns:r="http://schemas.openxmlformats.org/officeDocument/2006/relationships" id="263" r:id="R5c89f5b66d914d26"/>
+    <p:sldId xmlns:r="http://schemas.openxmlformats.org/officeDocument/2006/relationships" id="264" r:id="R6bcf3556df5e4722"/>
+    <p:sldId xmlns:r="http://schemas.openxmlformats.org/officeDocument/2006/relationships" id="265" r:id="Rea906614da444521"/>
+    <p:sldId xmlns:r="http://schemas.openxmlformats.org/officeDocument/2006/relationships" id="266" r:id="R0d7cdec97d4a44c3"/>
   </p:sldIdLst>
   <p:sldSz cx="12192000" cy="6858000"/>
   <p:notesSz cx="6858000" cy="9144000"/>
@@ -1271,7 +1271,7 @@
   </p:cSld>
   <p:clrMap bg1="lt1" tx1="dk1" bg2="lt2" tx2="dk2" accent1="accent1" accent2="accent2" accent3="accent3" accent4="accent4" accent5="accent5" accent6="accent6" hlink="hlink" folHlink="folHlink"/>
   <p:sldLayoutIdLst>
-    <p:sldLayoutId xmlns:r="http://schemas.openxmlformats.org/officeDocument/2006/relationships" id="2147483649" r:id="R706969d9fb9f4d78"/>
+    <p:sldLayoutId xmlns:r="http://schemas.openxmlformats.org/officeDocument/2006/relationships" id="2147483649" r:id="R8cf95c3e7e0044f1"/>
   </p:sldLayoutIdLst>
   <p:txStyles>
     <p:titleStyle>
@@ -1822,7 +1822,7 @@
           <p:cNvPr id="6" name="cover-eyebrow">
             <a:extLst xmlns:a="http://schemas.openxmlformats.org/drawingml/2006/main">
               <a:ext uri="{FF2B5EF4-FFF2-40B4-BE49-F238E27FC236}">
-                <a16:creationId xmlns:a16="http://schemas.microsoft.com/office/drawing/2014/main" id="{2BA9F034-14C0-4BB8-9F19-493ADA578C79}"/>
+                <a16:creationId xmlns:a16="http://schemas.microsoft.com/office/drawing/2014/main" id="{D9EC1DCF-0F7E-469B-97C0-7973931C17CF}"/>
               </a:ext>
             </a:extLst>
           </p:cNvPr>
@@ -1867,7 +1867,7 @@
           <p:cNvPr id="2" name="cover-title">
             <a:extLst xmlns:a="http://schemas.openxmlformats.org/drawingml/2006/main">
               <a:ext uri="{FF2B5EF4-FFF2-40B4-BE49-F238E27FC236}">
-                <a16:creationId xmlns:a16="http://schemas.microsoft.com/office/drawing/2014/main" id="{C027FAAB-E93A-45D2-ADAD-DA41268D9B0A}"/>
+                <a16:creationId xmlns:a16="http://schemas.microsoft.com/office/drawing/2014/main" id="{5A43A030-69E8-4BD1-B3EB-CBC8BFD8CD59}"/>
               </a:ext>
             </a:extLst>
           </p:cNvPr>
@@ -1935,7 +1935,7 @@
           <p:cNvPr id="4" name="cover-subtitle">
             <a:extLst xmlns:a="http://schemas.openxmlformats.org/drawingml/2006/main">
               <a:ext uri="{FF2B5EF4-FFF2-40B4-BE49-F238E27FC236}">
-                <a16:creationId xmlns:a16="http://schemas.microsoft.com/office/drawing/2014/main" id="{F3A7B825-ADCC-4B8C-ACCA-DC521DD78718}"/>
+                <a16:creationId xmlns:a16="http://schemas.microsoft.com/office/drawing/2014/main" id="{586D360B-C287-4542-8B23-C7840608C2BA}"/>
               </a:ext>
             </a:extLst>
           </p:cNvPr>
@@ -1980,7 +1980,7 @@
           <p:cNvPr id="5" name="cover-date">
             <a:extLst xmlns:a="http://schemas.openxmlformats.org/drawingml/2006/main">
               <a:ext uri="{FF2B5EF4-FFF2-40B4-BE49-F238E27FC236}">
-                <a16:creationId xmlns:a16="http://schemas.microsoft.com/office/drawing/2014/main" id="{6E4000C6-0988-41C7-8A32-0AF3A8F3AE7B}"/>
+                <a16:creationId xmlns:a16="http://schemas.microsoft.com/office/drawing/2014/main" id="{1140F853-A540-455F-B159-0C5B9C79AD7A}"/>
               </a:ext>
             </a:extLst>
           </p:cNvPr>
@@ -2023,7 +2023,7 @@
     </p:spTree>
     <p:extLst>
       <p:ext uri="{BB962C8B-B14F-4D97-AF65-F5344CB8AC3E}">
-        <p14:creationId xmlns:p14="http://schemas.microsoft.com/office/powerpoint/2010/main" val="1492193275"/>
+        <p14:creationId xmlns:p14="http://schemas.microsoft.com/office/powerpoint/2010/main" val="1547130106"/>
       </p:ext>
     </p:extLst>
   </p:cSld>
@@ -2054,7 +2054,7 @@
           <p:cNvPr id="20" name="slide-title">
             <a:extLst xmlns:a="http://schemas.openxmlformats.org/drawingml/2006/main">
               <a:ext uri="{FF2B5EF4-FFF2-40B4-BE49-F238E27FC236}">
-                <a16:creationId xmlns:a16="http://schemas.microsoft.com/office/drawing/2014/main" id="{461CE629-0D25-48DC-AE22-FCF6688707BB}"/>
+                <a16:creationId xmlns:a16="http://schemas.microsoft.com/office/drawing/2014/main" id="{45A2595D-C76A-4949-A692-EF9FB51EE15D}"/>
               </a:ext>
             </a:extLst>
           </p:cNvPr>
@@ -2099,7 +2099,7 @@
           <p:cNvPr id="2" name="status-now-label">
             <a:extLst xmlns:a="http://schemas.openxmlformats.org/drawingml/2006/main">
               <a:ext uri="{FF2B5EF4-FFF2-40B4-BE49-F238E27FC236}">
-                <a16:creationId xmlns:a16="http://schemas.microsoft.com/office/drawing/2014/main" id="{E668A8F2-DC50-4DFA-99E6-E0D7CCD54A21}"/>
+                <a16:creationId xmlns:a16="http://schemas.microsoft.com/office/drawing/2014/main" id="{E13AFDB3-1F76-4FBC-94C6-E81557D800F5}"/>
               </a:ext>
             </a:extLst>
           </p:cNvPr>
@@ -2144,7 +2144,7 @@
           <p:cNvPr id="3" name="status-now-body">
             <a:extLst xmlns:a="http://schemas.openxmlformats.org/drawingml/2006/main">
               <a:ext uri="{FF2B5EF4-FFF2-40B4-BE49-F238E27FC236}">
-                <a16:creationId xmlns:a16="http://schemas.microsoft.com/office/drawing/2014/main" id="{DECEC120-2765-4AC1-B1CD-7DD60E30CA15}"/>
+                <a16:creationId xmlns:a16="http://schemas.microsoft.com/office/drawing/2014/main" id="{C104FCF9-F7E7-4977-B190-37FCC1CCE1D7}"/>
               </a:ext>
             </a:extLst>
           </p:cNvPr>
@@ -2183,7 +2183,7 @@
 Proxy-greedy and random starts
 Fixed-K paired search (47 rows)
 Variable-K independent split/merge
-Full-week 333-row adapter</a:t>
+2,000-evaluation full-week run</a:t>
             </a:r>
           </a:p>
         </p:txBody>
@@ -2215,7 +2215,7 @@
           <p:cNvPr id="5" name="status-next-label">
             <a:extLst xmlns:a="http://schemas.openxmlformats.org/drawingml/2006/main">
               <a:ext uri="{FF2B5EF4-FFF2-40B4-BE49-F238E27FC236}">
-                <a16:creationId xmlns:a16="http://schemas.microsoft.com/office/drawing/2014/main" id="{415F0954-958C-43CE-ACDD-8180897CFE69}"/>
+                <a16:creationId xmlns:a16="http://schemas.microsoft.com/office/drawing/2014/main" id="{6AAD8D22-6AFB-4AEF-AD6E-4B3555258B82}"/>
               </a:ext>
             </a:extLst>
           </p:cNvPr>
@@ -2260,7 +2260,7 @@
           <p:cNvPr id="6" name="next-1-num">
             <a:extLst xmlns:a="http://schemas.openxmlformats.org/drawingml/2006/main">
               <a:ext uri="{FF2B5EF4-FFF2-40B4-BE49-F238E27FC236}">
-                <a16:creationId xmlns:a16="http://schemas.microsoft.com/office/drawing/2014/main" id="{EA4149EA-5709-491C-979B-B5791FEE59D5}"/>
+                <a16:creationId xmlns:a16="http://schemas.microsoft.com/office/drawing/2014/main" id="{FE4018B7-1E10-47B4-B314-CD6234C89A90}"/>
               </a:ext>
             </a:extLst>
           </p:cNvPr>
@@ -2305,7 +2305,7 @@
           <p:cNvPr id="7" name="next-1-title">
             <a:extLst xmlns:a="http://schemas.openxmlformats.org/drawingml/2006/main">
               <a:ext uri="{FF2B5EF4-FFF2-40B4-BE49-F238E27FC236}">
-                <a16:creationId xmlns:a16="http://schemas.microsoft.com/office/drawing/2014/main" id="{99D5CC4F-4C28-4E0C-B062-7E286C57E704}"/>
+                <a16:creationId xmlns:a16="http://schemas.microsoft.com/office/drawing/2014/main" id="{0F197381-00EF-46FD-AF7B-97E22174804F}"/>
               </a:ext>
             </a:extLst>
           </p:cNvPr>
@@ -2340,7 +2340,7 @@
               </a:defRPr>
             </a:pPr>
             <a:r>
-              <a:t>Land / sea</a:t>
+              <a:t>Projected covariance</a:t>
             </a:r>
           </a:p>
         </p:txBody>
@@ -2350,7 +2350,7 @@
           <p:cNvPr id="8" name="next-1-body">
             <a:extLst xmlns:a="http://schemas.openxmlformats.org/drawingml/2006/main">
               <a:ext uri="{FF2B5EF4-FFF2-40B4-BE49-F238E27FC236}">
-                <a16:creationId xmlns:a16="http://schemas.microsoft.com/office/drawing/2014/main" id="{3957073A-DF2E-4C04-B7AB-3BDCC477E6F0}"/>
+                <a16:creationId xmlns:a16="http://schemas.microsoft.com/office/drawing/2014/main" id="{3C668775-D0C3-41E1-9F30-3740ED81D760}"/>
               </a:ext>
             </a:extLst>
           </p:cNvPr>
@@ -2385,7 +2385,7 @@
               </a:defRPr>
             </a:pPr>
             <a:r>
-              <a:t>Diagnose boundary crossing or impose an explicit constraint</a:t>
+              <a:t>Implement Bₚ=PBPᵀ with consistent mapping and normalization</a:t>
             </a:r>
           </a:p>
         </p:txBody>
@@ -2395,7 +2395,7 @@
           <p:cNvPr id="9" name="next-2-num">
             <a:extLst xmlns:a="http://schemas.openxmlformats.org/drawingml/2006/main">
               <a:ext uri="{FF2B5EF4-FFF2-40B4-BE49-F238E27FC236}">
-                <a16:creationId xmlns:a16="http://schemas.microsoft.com/office/drawing/2014/main" id="{387A64FF-0495-4111-958B-CAEDD182E84D}"/>
+                <a16:creationId xmlns:a16="http://schemas.microsoft.com/office/drawing/2014/main" id="{F0371B96-D623-4EFD-A809-316A63F4BBB0}"/>
               </a:ext>
             </a:extLst>
           </p:cNvPr>
@@ -2440,7 +2440,7 @@
           <p:cNvPr id="10" name="next-2-title">
             <a:extLst xmlns:a="http://schemas.openxmlformats.org/drawingml/2006/main">
               <a:ext uri="{FF2B5EF4-FFF2-40B4-BE49-F238E27FC236}">
-                <a16:creationId xmlns:a16="http://schemas.microsoft.com/office/drawing/2014/main" id="{86DF2F5C-A721-4441-8718-5DE7D36C0043}"/>
+                <a16:creationId xmlns:a16="http://schemas.microsoft.com/office/drawing/2014/main" id="{097F29AE-1259-4406-B787-19F3D2899241}"/>
               </a:ext>
             </a:extLst>
           </p:cNvPr>
@@ -2475,7 +2475,7 @@
               </a:defRPr>
             </a:pPr>
             <a:r>
-              <a:t>Projected covariance</a:t>
+              <a:t>Land / sea</a:t>
             </a:r>
           </a:p>
         </p:txBody>
@@ -2485,7 +2485,7 @@
           <p:cNvPr id="11" name="next-2-body">
             <a:extLst xmlns:a="http://schemas.openxmlformats.org/drawingml/2006/main">
               <a:ext uri="{FF2B5EF4-FFF2-40B4-BE49-F238E27FC236}">
-                <a16:creationId xmlns:a16="http://schemas.microsoft.com/office/drawing/2014/main" id="{521B16BA-E201-4ED4-8A32-ABADE9A8C1A5}"/>
+                <a16:creationId xmlns:a16="http://schemas.microsoft.com/office/drawing/2014/main" id="{AAF4FA6E-60FA-4198-AA9A-C0AE3298F6E3}"/>
               </a:ext>
             </a:extLst>
           </p:cNvPr>
@@ -2520,7 +2520,7 @@
               </a:defRPr>
             </a:pPr>
             <a:r>
-              <a:t>Implement Bₚ=PBPᵀ and compare conclusions</a:t>
+              <a:t>Diagnose boundary crossing or impose an explicit constraint</a:t>
             </a:r>
           </a:p>
         </p:txBody>
@@ -2530,7 +2530,7 @@
           <p:cNvPr id="12" name="next-3-num">
             <a:extLst xmlns:a="http://schemas.openxmlformats.org/drawingml/2006/main">
               <a:ext uri="{FF2B5EF4-FFF2-40B4-BE49-F238E27FC236}">
-                <a16:creationId xmlns:a16="http://schemas.microsoft.com/office/drawing/2014/main" id="{4F2F4B5A-1871-4F5F-9A9A-3C8E8697E018}"/>
+                <a16:creationId xmlns:a16="http://schemas.microsoft.com/office/drawing/2014/main" id="{DBF6138E-D531-4C69-B1F0-C8922D94E606}"/>
               </a:ext>
             </a:extLst>
           </p:cNvPr>
@@ -2575,7 +2575,7 @@
           <p:cNvPr id="13" name="next-3-title">
             <a:extLst xmlns:a="http://schemas.openxmlformats.org/drawingml/2006/main">
               <a:ext uri="{FF2B5EF4-FFF2-40B4-BE49-F238E27FC236}">
-                <a16:creationId xmlns:a16="http://schemas.microsoft.com/office/drawing/2014/main" id="{C5173741-65E6-4088-A621-D3E6F5D2263A}"/>
+                <a16:creationId xmlns:a16="http://schemas.microsoft.com/office/drawing/2014/main" id="{261F6606-F367-458C-82A9-4AF75B3AF3EA}"/>
               </a:ext>
             </a:extLst>
           </p:cNvPr>
@@ -2620,7 +2620,7 @@
           <p:cNvPr id="14" name="next-3-body">
             <a:extLst xmlns:a="http://schemas.openxmlformats.org/drawingml/2006/main">
               <a:ext uri="{FF2B5EF4-FFF2-40B4-BE49-F238E27FC236}">
-                <a16:creationId xmlns:a16="http://schemas.microsoft.com/office/drawing/2014/main" id="{31CB4C97-1FD1-4244-BCFA-3DE91993136B}"/>
+                <a16:creationId xmlns:a16="http://schemas.microsoft.com/office/drawing/2014/main" id="{7A15A36B-3FDB-4281-9EA4-5B6AA7F5C13E}"/>
               </a:ext>
             </a:extLst>
           </p:cNvPr>
@@ -2665,7 +2665,7 @@
           <p:cNvPr id="15" name="next-4-num">
             <a:extLst xmlns:a="http://schemas.openxmlformats.org/drawingml/2006/main">
               <a:ext uri="{FF2B5EF4-FFF2-40B4-BE49-F238E27FC236}">
-                <a16:creationId xmlns:a16="http://schemas.microsoft.com/office/drawing/2014/main" id="{DA9A9239-60C3-43DC-8C97-A5E14A847850}"/>
+                <a16:creationId xmlns:a16="http://schemas.microsoft.com/office/drawing/2014/main" id="{BB276CEA-8AC5-4D5F-B796-6A585B9B2952}"/>
               </a:ext>
             </a:extLst>
           </p:cNvPr>
@@ -2710,7 +2710,7 @@
           <p:cNvPr id="16" name="next-4-title">
             <a:extLst xmlns:a="http://schemas.openxmlformats.org/drawingml/2006/main">
               <a:ext uri="{FF2B5EF4-FFF2-40B4-BE49-F238E27FC236}">
-                <a16:creationId xmlns:a16="http://schemas.microsoft.com/office/drawing/2014/main" id="{D8C74203-CAB5-4415-9E0D-F10FEFCA5702}"/>
+                <a16:creationId xmlns:a16="http://schemas.microsoft.com/office/drawing/2014/main" id="{D5763991-3856-4776-97FB-B8CDFF12DAB4}"/>
               </a:ext>
             </a:extLst>
           </p:cNvPr>
@@ -2755,7 +2755,7 @@
           <p:cNvPr id="17" name="next-4-body">
             <a:extLst xmlns:a="http://schemas.openxmlformats.org/drawingml/2006/main">
               <a:ext uri="{FF2B5EF4-FFF2-40B4-BE49-F238E27FC236}">
-                <a16:creationId xmlns:a16="http://schemas.microsoft.com/office/drawing/2014/main" id="{D6FCFF3A-D8CE-408E-8E78-0799E89634B2}"/>
+                <a16:creationId xmlns:a16="http://schemas.microsoft.com/office/drawing/2014/main" id="{4BF6FF45-4D9D-410B-8A04-9DB0390C8D6D}"/>
               </a:ext>
             </a:extLst>
           </p:cNvPr>
@@ -2800,7 +2800,7 @@
           <p:cNvPr id="18" name="method-source">
             <a:extLst xmlns:a="http://schemas.openxmlformats.org/drawingml/2006/main">
               <a:ext uri="{FF2B5EF4-FFF2-40B4-BE49-F238E27FC236}">
-                <a16:creationId xmlns:a16="http://schemas.microsoft.com/office/drawing/2014/main" id="{1DEFDC05-F69F-46EA-8C74-B08B73924CEC}"/>
+                <a16:creationId xmlns:a16="http://schemas.microsoft.com/office/drawing/2014/main" id="{934E8861-0CF4-4BAD-ABB0-EB66E6D24771}"/>
               </a:ext>
             </a:extLst>
           </p:cNvPr>
@@ -2845,7 +2845,7 @@
           <p:cNvPr id="19" name="page-number">
             <a:extLst xmlns:a="http://schemas.openxmlformats.org/drawingml/2006/main">
               <a:ext uri="{FF2B5EF4-FFF2-40B4-BE49-F238E27FC236}">
-                <a16:creationId xmlns:a16="http://schemas.microsoft.com/office/drawing/2014/main" id="{42F6C7CC-3CB4-4021-843C-C93F43C0AAED}"/>
+                <a16:creationId xmlns:a16="http://schemas.microsoft.com/office/drawing/2014/main" id="{BC36B454-7887-479F-A133-24F6DFE647AD}"/>
               </a:ext>
             </a:extLst>
           </p:cNvPr>
@@ -2888,7 +2888,7 @@
     </p:spTree>
     <p:extLst>
       <p:ext uri="{BB962C8B-B14F-4D97-AF65-F5344CB8AC3E}">
-        <p14:creationId xmlns:p14="http://schemas.microsoft.com/office/powerpoint/2010/main" val="1022724949"/>
+        <p14:creationId xmlns:p14="http://schemas.microsoft.com/office/powerpoint/2010/main" val="1194172601"/>
       </p:ext>
     </p:extLst>
   </p:cSld>
@@ -2919,7 +2919,7 @@
           <p:cNvPr id="6" name="takeaway-eyebrow">
             <a:extLst xmlns:a="http://schemas.openxmlformats.org/drawingml/2006/main">
               <a:ext uri="{FF2B5EF4-FFF2-40B4-BE49-F238E27FC236}">
-                <a16:creationId xmlns:a16="http://schemas.microsoft.com/office/drawing/2014/main" id="{D131BA70-AEEA-48E7-B4AB-8DDD5BB9F901}"/>
+                <a16:creationId xmlns:a16="http://schemas.microsoft.com/office/drawing/2014/main" id="{202E8E79-204C-4242-B53E-F6DE7F53AE5B}"/>
               </a:ext>
             </a:extLst>
           </p:cNvPr>
@@ -2964,7 +2964,7 @@
           <p:cNvPr id="2" name="takeaway-title">
             <a:extLst xmlns:a="http://schemas.openxmlformats.org/drawingml/2006/main">
               <a:ext uri="{FF2B5EF4-FFF2-40B4-BE49-F238E27FC236}">
-                <a16:creationId xmlns:a16="http://schemas.microsoft.com/office/drawing/2014/main" id="{3F026686-466F-4B10-8E13-CF5E595461FD}"/>
+                <a16:creationId xmlns:a16="http://schemas.microsoft.com/office/drawing/2014/main" id="{FE293DFC-C84C-454A-BA5B-465D728C5205}"/>
               </a:ext>
             </a:extLst>
           </p:cNvPr>
@@ -2984,7 +2984,7 @@
         </p:spPr>
         <p:txBody>
           <a:bodyPr xmlns:a="http://schemas.openxmlformats.org/drawingml/2006/main" wrap="square" lIns="0" tIns="0" rIns="0" bIns="0" anchor="b">
-            <a:normAutofit fontScale="100000"/>
+            <a:normAutofit fontScale="93863"/>
           </a:bodyPr>
           <a:lstStyle xmlns:a="http://schemas.openxmlformats.org/drawingml/2006/main"/>
           <a:p xmlns:a="http://schemas.openxmlformats.org/drawingml/2006/main">
@@ -2999,8 +2999,8 @@
               </a:defRPr>
             </a:pPr>
             <a:r>
-              <a:t>The gain persists at full-week scale;
-K remains unstable.</a:t>
+              <a:t>The longer search improves DFS at K=25;
+retained-information claims must wait.</a:t>
             </a:r>
           </a:p>
         </p:txBody>
@@ -3032,7 +3032,7 @@
           <p:cNvPr id="4" name="takeaway-body">
             <a:extLst xmlns:a="http://schemas.openxmlformats.org/drawingml/2006/main">
               <a:ext uri="{FF2B5EF4-FFF2-40B4-BE49-F238E27FC236}">
-                <a16:creationId xmlns:a16="http://schemas.microsoft.com/office/drawing/2014/main" id="{51072193-6FA0-4954-84FA-6EDC26CB35D6}"/>
+                <a16:creationId xmlns:a16="http://schemas.microsoft.com/office/drawing/2014/main" id="{C1281ECB-066D-44ED-92B8-FB1AF092C3F2}"/>
               </a:ext>
             </a:extLst>
           </p:cNvPr>
@@ -3067,7 +3067,7 @@
               </a:defRPr>
             </a:pPr>
             <a:r>
-              <a:t>Next: multi-seed and longer-run robustness, projected covariance, land/sea treatment, and posterior integration.</a:t>
+              <a:t>Next: Bₚ=PBPᵀ with consistent mapping, then multi-seed robustness, land/sea treatment, and posterior integration.</a:t>
             </a:r>
           </a:p>
         </p:txBody>
@@ -3077,7 +3077,7 @@
           <p:cNvPr id="5" name="page-number">
             <a:extLst xmlns:a="http://schemas.openxmlformats.org/drawingml/2006/main">
               <a:ext uri="{FF2B5EF4-FFF2-40B4-BE49-F238E27FC236}">
-                <a16:creationId xmlns:a16="http://schemas.microsoft.com/office/drawing/2014/main" id="{63B871DE-3ACB-4719-846A-8B67A04256B1}"/>
+                <a16:creationId xmlns:a16="http://schemas.microsoft.com/office/drawing/2014/main" id="{8FBECEC7-0E50-4E89-8FC2-3FE400A5D7DD}"/>
               </a:ext>
             </a:extLst>
           </p:cNvPr>
@@ -3120,7 +3120,7 @@
     </p:spTree>
     <p:extLst>
       <p:ext uri="{BB962C8B-B14F-4D97-AF65-F5344CB8AC3E}">
-        <p14:creationId xmlns:p14="http://schemas.microsoft.com/office/powerpoint/2010/main" val="1433346022"/>
+        <p14:creationId xmlns:p14="http://schemas.microsoft.com/office/powerpoint/2010/main" val="1898643095"/>
       </p:ext>
     </p:extLst>
   </p:cSld>
@@ -3151,7 +3151,7 @@
           <p:cNvPr id="27" name="slide-title">
             <a:extLst xmlns:a="http://schemas.openxmlformats.org/drawingml/2006/main">
               <a:ext uri="{FF2B5EF4-FFF2-40B4-BE49-F238E27FC236}">
-                <a16:creationId xmlns:a16="http://schemas.microsoft.com/office/drawing/2014/main" id="{0E96C60F-B54E-41CB-8BAE-C8C3BA256961}"/>
+                <a16:creationId xmlns:a16="http://schemas.microsoft.com/office/drawing/2014/main" id="{5C056D05-7A6D-4849-93A6-6393A4AD2C24}"/>
               </a:ext>
             </a:extLst>
           </p:cNvPr>
@@ -3196,7 +3196,7 @@
           <p:cNvPr id="2" name="motivation-claim">
             <a:extLst xmlns:a="http://schemas.openxmlformats.org/drawingml/2006/main">
               <a:ext uri="{FF2B5EF4-FFF2-40B4-BE49-F238E27FC236}">
-                <a16:creationId xmlns:a16="http://schemas.microsoft.com/office/drawing/2014/main" id="{AAE4D7D6-2895-4448-8AE3-F161EC5B8DDA}"/>
+                <a16:creationId xmlns:a16="http://schemas.microsoft.com/office/drawing/2014/main" id="{C295D746-FB3C-49F2-9B9D-74ECABA15666}"/>
               </a:ext>
             </a:extLst>
           </p:cNvPr>
@@ -3241,7 +3241,7 @@
           <p:cNvPr id="3" name="motivation-body">
             <a:extLst xmlns:a="http://schemas.openxmlformats.org/drawingml/2006/main">
               <a:ext uri="{FF2B5EF4-FFF2-40B4-BE49-F238E27FC236}">
-                <a16:creationId xmlns:a16="http://schemas.microsoft.com/office/drawing/2014/main" id="{8F6AD7F9-819C-4347-98BD-DCE5A231B318}"/>
+                <a16:creationId xmlns:a16="http://schemas.microsoft.com/office/drawing/2014/main" id="{5CF6C4BE-B6B9-4014-B569-2170340FF467}"/>
               </a:ext>
             </a:extLst>
           </p:cNvPr>
@@ -3286,7 +3286,7 @@
           <p:cNvPr id="4" name="fixed-label">
             <a:extLst xmlns:a="http://schemas.openxmlformats.org/drawingml/2006/main">
               <a:ext uri="{FF2B5EF4-FFF2-40B4-BE49-F238E27FC236}">
-                <a16:creationId xmlns:a16="http://schemas.microsoft.com/office/drawing/2014/main" id="{14A40F0D-1527-4739-BAAC-D6A2966953E5}"/>
+                <a16:creationId xmlns:a16="http://schemas.microsoft.com/office/drawing/2014/main" id="{D74B9401-B730-4892-859C-9D26726AA8C5}"/>
               </a:ext>
             </a:extLst>
           </p:cNvPr>
@@ -3331,7 +3331,7 @@
           <p:cNvPr id="5" name="adaptive-label">
             <a:extLst xmlns:a="http://schemas.openxmlformats.org/drawingml/2006/main">
               <a:ext uri="{FF2B5EF4-FFF2-40B4-BE49-F238E27FC236}">
-                <a16:creationId xmlns:a16="http://schemas.microsoft.com/office/drawing/2014/main" id="{2EFDB028-A745-4EA1-848E-B22B05926C74}"/>
+                <a16:creationId xmlns:a16="http://schemas.microsoft.com/office/drawing/2014/main" id="{09FEF958-6655-4A12-8BE1-E1A56F3CF330}"/>
               </a:ext>
             </a:extLst>
           </p:cNvPr>
@@ -3376,7 +3376,7 @@
           <p:cNvPr id="6" name="transition-arrow">
             <a:extLst xmlns:a="http://schemas.openxmlformats.org/drawingml/2006/main">
               <a:ext uri="{FF2B5EF4-FFF2-40B4-BE49-F238E27FC236}">
-                <a16:creationId xmlns:a16="http://schemas.microsoft.com/office/drawing/2014/main" id="{3FEA7894-4748-4235-A368-3E68B8208968}"/>
+                <a16:creationId xmlns:a16="http://schemas.microsoft.com/office/drawing/2014/main" id="{26408F59-ED07-48E1-9953-D00DFDBA37F8}"/>
               </a:ext>
             </a:extLst>
           </p:cNvPr>
@@ -3421,7 +3421,7 @@
           <p:cNvPr id="7" name="motivation-question">
             <a:extLst xmlns:a="http://schemas.openxmlformats.org/drawingml/2006/main">
               <a:ext uri="{FF2B5EF4-FFF2-40B4-BE49-F238E27FC236}">
-                <a16:creationId xmlns:a16="http://schemas.microsoft.com/office/drawing/2014/main" id="{C5259DFD-C7A3-499D-A03C-7497E31D49DB}"/>
+                <a16:creationId xmlns:a16="http://schemas.microsoft.com/office/drawing/2014/main" id="{FB6D2A44-179E-4F32-BF8D-93ABB96A9886}"/>
               </a:ext>
             </a:extLst>
           </p:cNvPr>
@@ -3466,7 +3466,7 @@
           <p:cNvPr id="8" name="page-number">
             <a:extLst xmlns:a="http://schemas.openxmlformats.org/drawingml/2006/main">
               <a:ext uri="{FF2B5EF4-FFF2-40B4-BE49-F238E27FC236}">
-                <a16:creationId xmlns:a16="http://schemas.microsoft.com/office/drawing/2014/main" id="{65B41343-83F6-4DEB-BE61-652B73AD7B0B}"/>
+                <a16:creationId xmlns:a16="http://schemas.microsoft.com/office/drawing/2014/main" id="{AE28D6E4-ACB7-4A81-B01B-BA901CEF7B66}"/>
               </a:ext>
             </a:extLst>
           </p:cNvPr>
@@ -3511,7 +3511,7 @@
           <p:cNvPr id="9" name="grid-outline">
             <a:extLst xmlns:a="http://schemas.openxmlformats.org/drawingml/2006/main">
               <a:ext uri="{FF2B5EF4-FFF2-40B4-BE49-F238E27FC236}">
-                <a16:creationId xmlns:a16="http://schemas.microsoft.com/office/drawing/2014/main" id="{83989057-742B-41A9-8DD6-FCE859C3E490}"/>
+                <a16:creationId xmlns:a16="http://schemas.microsoft.com/office/drawing/2014/main" id="{D9EC4B7B-6E2E-45E6-A839-AF746E351027}"/>
               </a:ext>
             </a:extLst>
           </p:cNvPr>
@@ -3742,7 +3742,7 @@
           <p:cNvPr id="19" name="sensitivity-hotspot">
             <a:extLst xmlns:a="http://schemas.openxmlformats.org/drawingml/2006/main">
               <a:ext uri="{FF2B5EF4-FFF2-40B4-BE49-F238E27FC236}">
-                <a16:creationId xmlns:a16="http://schemas.microsoft.com/office/drawing/2014/main" id="{7D845F03-18A3-4A41-81BB-976A38A49E77}"/>
+                <a16:creationId xmlns:a16="http://schemas.microsoft.com/office/drawing/2014/main" id="{3EA8D0CB-7534-494F-B2BC-11A82CA742F9}"/>
               </a:ext>
             </a:extLst>
           </p:cNvPr>
@@ -3775,7 +3775,7 @@
           <p:cNvPr id="20" name="grid-outline">
             <a:extLst xmlns:a="http://schemas.openxmlformats.org/drawingml/2006/main">
               <a:ext uri="{FF2B5EF4-FFF2-40B4-BE49-F238E27FC236}">
-                <a16:creationId xmlns:a16="http://schemas.microsoft.com/office/drawing/2014/main" id="{17498537-5979-42EB-A06E-FF176F356ED0}"/>
+                <a16:creationId xmlns:a16="http://schemas.microsoft.com/office/drawing/2014/main" id="{2A9E926B-91A2-4164-B67B-36FBD62B944C}"/>
               </a:ext>
             </a:extLst>
           </p:cNvPr>
@@ -3918,7 +3918,7 @@
           <p:cNvPr id="26" name="sensitivity-hotspot">
             <a:extLst xmlns:a="http://schemas.openxmlformats.org/drawingml/2006/main">
               <a:ext uri="{FF2B5EF4-FFF2-40B4-BE49-F238E27FC236}">
-                <a16:creationId xmlns:a16="http://schemas.microsoft.com/office/drawing/2014/main" id="{00DFA441-CD6F-4E5F-AF46-DF53B1D77EDA}"/>
+                <a16:creationId xmlns:a16="http://schemas.microsoft.com/office/drawing/2014/main" id="{759A92A5-5E94-45E8-8684-9D1E020E4560}"/>
               </a:ext>
             </a:extLst>
           </p:cNvPr>
@@ -3949,7 +3949,7 @@
     </p:spTree>
     <p:extLst>
       <p:ext uri="{BB962C8B-B14F-4D97-AF65-F5344CB8AC3E}">
-        <p14:creationId xmlns:p14="http://schemas.microsoft.com/office/powerpoint/2010/main" val="442543241"/>
+        <p14:creationId xmlns:p14="http://schemas.microsoft.com/office/powerpoint/2010/main" val="27375878"/>
       </p:ext>
     </p:extLst>
   </p:cSld>
@@ -3980,7 +3980,7 @@
           <p:cNvPr id="8" name="slide-title">
             <a:extLst xmlns:a="http://schemas.openxmlformats.org/drawingml/2006/main">
               <a:ext uri="{FF2B5EF4-FFF2-40B4-BE49-F238E27FC236}">
-                <a16:creationId xmlns:a16="http://schemas.microsoft.com/office/drawing/2014/main" id="{F89A0659-A768-4668-80DB-2B2B1B6FE210}"/>
+                <a16:creationId xmlns:a16="http://schemas.microsoft.com/office/drawing/2014/main" id="{42FE37A8-EFF2-4399-8E83-D97BABC6FEA1}"/>
               </a:ext>
             </a:extLst>
           </p:cNvPr>
@@ -4047,7 +4047,7 @@
           <p:cNvPr id="3" name="scope-yes">
             <a:extLst xmlns:a="http://schemas.openxmlformats.org/drawingml/2006/main">
               <a:ext uri="{FF2B5EF4-FFF2-40B4-BE49-F238E27FC236}">
-                <a16:creationId xmlns:a16="http://schemas.microsoft.com/office/drawing/2014/main" id="{40D122E5-5642-412C-9739-58B420D31FEA}"/>
+                <a16:creationId xmlns:a16="http://schemas.microsoft.com/office/drawing/2014/main" id="{75CF6A54-8749-4BFE-9AE1-1C3625DC7433}"/>
               </a:ext>
             </a:extLst>
           </p:cNvPr>
@@ -4092,7 +4092,7 @@
           <p:cNvPr id="4" name="scope-yes-body">
             <a:extLst xmlns:a="http://schemas.openxmlformats.org/drawingml/2006/main">
               <a:ext uri="{FF2B5EF4-FFF2-40B4-BE49-F238E27FC236}">
-                <a16:creationId xmlns:a16="http://schemas.microsoft.com/office/drawing/2014/main" id="{5410B416-26F6-40BB-A78B-760935458EAA}"/>
+                <a16:creationId xmlns:a16="http://schemas.microsoft.com/office/drawing/2014/main" id="{D61A5276-CA02-4F0C-B2EF-E45B1A667F13}"/>
               </a:ext>
             </a:extLst>
           </p:cNvPr>
@@ -4140,7 +4140,7 @@
           <p:cNvPr id="5" name="scope-no">
             <a:extLst xmlns:a="http://schemas.openxmlformats.org/drawingml/2006/main">
               <a:ext uri="{FF2B5EF4-FFF2-40B4-BE49-F238E27FC236}">
-                <a16:creationId xmlns:a16="http://schemas.microsoft.com/office/drawing/2014/main" id="{F5D73448-545B-479F-B091-96D62402D465}"/>
+                <a16:creationId xmlns:a16="http://schemas.microsoft.com/office/drawing/2014/main" id="{5BFDA92D-7D43-4D84-99E5-09A3DDF83180}"/>
               </a:ext>
             </a:extLst>
           </p:cNvPr>
@@ -4185,7 +4185,7 @@
           <p:cNvPr id="6" name="scope-no-body">
             <a:extLst xmlns:a="http://schemas.openxmlformats.org/drawingml/2006/main">
               <a:ext uri="{FF2B5EF4-FFF2-40B4-BE49-F238E27FC236}">
-                <a16:creationId xmlns:a16="http://schemas.microsoft.com/office/drawing/2014/main" id="{16AB7CA9-DD2C-463E-BA35-B27E59A0569C}"/>
+                <a16:creationId xmlns:a16="http://schemas.microsoft.com/office/drawing/2014/main" id="{D9E62D7C-13EE-4DDD-AAEA-1A2501DFE2E4}"/>
               </a:ext>
             </a:extLst>
           </p:cNvPr>
@@ -4233,7 +4233,7 @@
           <p:cNvPr id="7" name="page-number">
             <a:extLst xmlns:a="http://schemas.openxmlformats.org/drawingml/2006/main">
               <a:ext uri="{FF2B5EF4-FFF2-40B4-BE49-F238E27FC236}">
-                <a16:creationId xmlns:a16="http://schemas.microsoft.com/office/drawing/2014/main" id="{A277CFE0-9D4B-4CAB-A2D1-D84F33AA4702}"/>
+                <a16:creationId xmlns:a16="http://schemas.microsoft.com/office/drawing/2014/main" id="{174520D1-927A-4CE5-890A-50B3D155191F}"/>
               </a:ext>
             </a:extLst>
           </p:cNvPr>
@@ -4276,7 +4276,7 @@
     </p:spTree>
     <p:extLst>
       <p:ext uri="{BB962C8B-B14F-4D97-AF65-F5344CB8AC3E}">
-        <p14:creationId xmlns:p14="http://schemas.microsoft.com/office/powerpoint/2010/main" val="98662798"/>
+        <p14:creationId xmlns:p14="http://schemas.microsoft.com/office/powerpoint/2010/main" val="1207211060"/>
       </p:ext>
     </p:extLst>
   </p:cSld>
@@ -4307,7 +4307,7 @@
           <p:cNvPr id="22" name="slide-title">
             <a:extLst xmlns:a="http://schemas.openxmlformats.org/drawingml/2006/main">
               <a:ext uri="{FF2B5EF4-FFF2-40B4-BE49-F238E27FC236}">
-                <a16:creationId xmlns:a16="http://schemas.microsoft.com/office/drawing/2014/main" id="{37EAE658-E666-4CF3-B5F5-A45B54017B7F}"/>
+                <a16:creationId xmlns:a16="http://schemas.microsoft.com/office/drawing/2014/main" id="{5F21BD31-DE67-4CC6-BE13-C162AA4801EF}"/>
               </a:ext>
             </a:extLst>
           </p:cNvPr>
@@ -4418,7 +4418,7 @@
           <p:cNvPr id="5" name="pipe-box-1">
             <a:extLst xmlns:a="http://schemas.openxmlformats.org/drawingml/2006/main">
               <a:ext uri="{FF2B5EF4-FFF2-40B4-BE49-F238E27FC236}">
-                <a16:creationId xmlns:a16="http://schemas.microsoft.com/office/drawing/2014/main" id="{A922F2D9-9716-4572-A22A-7135C47EFFB2}"/>
+                <a16:creationId xmlns:a16="http://schemas.microsoft.com/office/drawing/2014/main" id="{378D5697-82D2-4768-8174-3DD6384B7AC9}"/>
               </a:ext>
             </a:extLst>
           </p:cNvPr>
@@ -4451,7 +4451,7 @@
           <p:cNvPr id="6" name="pipe-box-2">
             <a:extLst xmlns:a="http://schemas.openxmlformats.org/drawingml/2006/main">
               <a:ext uri="{FF2B5EF4-FFF2-40B4-BE49-F238E27FC236}">
-                <a16:creationId xmlns:a16="http://schemas.microsoft.com/office/drawing/2014/main" id="{25827EA0-19B9-44BF-B441-0FD06E580137}"/>
+                <a16:creationId xmlns:a16="http://schemas.microsoft.com/office/drawing/2014/main" id="{39F19EE4-3B63-48AD-A15C-43C51988B3CC}"/>
               </a:ext>
             </a:extLst>
           </p:cNvPr>
@@ -4484,7 +4484,7 @@
           <p:cNvPr id="7" name="pipe-box-3">
             <a:extLst xmlns:a="http://schemas.openxmlformats.org/drawingml/2006/main">
               <a:ext uri="{FF2B5EF4-FFF2-40B4-BE49-F238E27FC236}">
-                <a16:creationId xmlns:a16="http://schemas.microsoft.com/office/drawing/2014/main" id="{995F37C1-8974-4BDF-B6AC-71C5BBF0BC3B}"/>
+                <a16:creationId xmlns:a16="http://schemas.microsoft.com/office/drawing/2014/main" id="{841FE659-1E9A-4FEF-9ABA-4727A13EA35B}"/>
               </a:ext>
             </a:extLst>
           </p:cNvPr>
@@ -4517,7 +4517,7 @@
           <p:cNvPr id="8" name="pipe-box-4">
             <a:extLst xmlns:a="http://schemas.openxmlformats.org/drawingml/2006/main">
               <a:ext uri="{FF2B5EF4-FFF2-40B4-BE49-F238E27FC236}">
-                <a16:creationId xmlns:a16="http://schemas.microsoft.com/office/drawing/2014/main" id="{C991C29D-F570-4552-872E-CF68EAD03FFD}"/>
+                <a16:creationId xmlns:a16="http://schemas.microsoft.com/office/drawing/2014/main" id="{F9C39E0D-814E-481F-A912-0D7AD8D97694}"/>
               </a:ext>
             </a:extLst>
           </p:cNvPr>
@@ -4550,7 +4550,7 @@
           <p:cNvPr id="9" name="step-1">
             <a:extLst xmlns:a="http://schemas.openxmlformats.org/drawingml/2006/main">
               <a:ext uri="{FF2B5EF4-FFF2-40B4-BE49-F238E27FC236}">
-                <a16:creationId xmlns:a16="http://schemas.microsoft.com/office/drawing/2014/main" id="{98E93FBC-B23F-4323-A502-C784A62438B9}"/>
+                <a16:creationId xmlns:a16="http://schemas.microsoft.com/office/drawing/2014/main" id="{45C7C56E-BFA8-4D35-BE01-5ECF62AA1F58}"/>
               </a:ext>
             </a:extLst>
           </p:cNvPr>
@@ -4595,7 +4595,7 @@
           <p:cNvPr id="10" name="step-2">
             <a:extLst xmlns:a="http://schemas.openxmlformats.org/drawingml/2006/main">
               <a:ext uri="{FF2B5EF4-FFF2-40B4-BE49-F238E27FC236}">
-                <a16:creationId xmlns:a16="http://schemas.microsoft.com/office/drawing/2014/main" id="{64809A83-3957-4136-B47F-9BC70C728C82}"/>
+                <a16:creationId xmlns:a16="http://schemas.microsoft.com/office/drawing/2014/main" id="{42F02E1A-2B1A-495D-BC57-F3BDEF22FD91}"/>
               </a:ext>
             </a:extLst>
           </p:cNvPr>
@@ -4640,7 +4640,7 @@
           <p:cNvPr id="11" name="step-3">
             <a:extLst xmlns:a="http://schemas.openxmlformats.org/drawingml/2006/main">
               <a:ext uri="{FF2B5EF4-FFF2-40B4-BE49-F238E27FC236}">
-                <a16:creationId xmlns:a16="http://schemas.microsoft.com/office/drawing/2014/main" id="{6E4F44B7-2B4C-4A1D-952E-4B0456C81CBD}"/>
+                <a16:creationId xmlns:a16="http://schemas.microsoft.com/office/drawing/2014/main" id="{11A11C39-DD54-4AA8-BBF0-C5413F8ABC8F}"/>
               </a:ext>
             </a:extLst>
           </p:cNvPr>
@@ -4685,7 +4685,7 @@
           <p:cNvPr id="12" name="step-4">
             <a:extLst xmlns:a="http://schemas.openxmlformats.org/drawingml/2006/main">
               <a:ext uri="{FF2B5EF4-FFF2-40B4-BE49-F238E27FC236}">
-                <a16:creationId xmlns:a16="http://schemas.microsoft.com/office/drawing/2014/main" id="{573931CE-8DF1-433A-AE63-C9DCAACA2F6C}"/>
+                <a16:creationId xmlns:a16="http://schemas.microsoft.com/office/drawing/2014/main" id="{B2A77500-866C-4E14-B02B-7C60AC545201}"/>
               </a:ext>
             </a:extLst>
           </p:cNvPr>
@@ -4730,7 +4730,7 @@
           <p:cNvPr id="13" name="pipe-text-1">
             <a:extLst xmlns:a="http://schemas.openxmlformats.org/drawingml/2006/main">
               <a:ext uri="{FF2B5EF4-FFF2-40B4-BE49-F238E27FC236}">
-                <a16:creationId xmlns:a16="http://schemas.microsoft.com/office/drawing/2014/main" id="{D82ED8D9-347A-4978-96CD-33628E69F086}"/>
+                <a16:creationId xmlns:a16="http://schemas.microsoft.com/office/drawing/2014/main" id="{A4267F69-AD79-451D-BFFB-C68B57BFF760}"/>
               </a:ext>
             </a:extLst>
           </p:cNvPr>
@@ -4776,7 +4776,7 @@
           <p:cNvPr id="14" name="pipe-text-2">
             <a:extLst xmlns:a="http://schemas.openxmlformats.org/drawingml/2006/main">
               <a:ext uri="{FF2B5EF4-FFF2-40B4-BE49-F238E27FC236}">
-                <a16:creationId xmlns:a16="http://schemas.microsoft.com/office/drawing/2014/main" id="{FE548D68-43E8-499B-B01B-FC9835520FEC}"/>
+                <a16:creationId xmlns:a16="http://schemas.microsoft.com/office/drawing/2014/main" id="{DCF9D51B-3930-47B3-9413-6E2BFF09FC34}"/>
               </a:ext>
             </a:extLst>
           </p:cNvPr>
@@ -4822,7 +4822,7 @@
           <p:cNvPr id="15" name="pipe-text-3">
             <a:extLst xmlns:a="http://schemas.openxmlformats.org/drawingml/2006/main">
               <a:ext uri="{FF2B5EF4-FFF2-40B4-BE49-F238E27FC236}">
-                <a16:creationId xmlns:a16="http://schemas.microsoft.com/office/drawing/2014/main" id="{8C551245-17B2-4185-8299-9BE0A3FA625A}"/>
+                <a16:creationId xmlns:a16="http://schemas.microsoft.com/office/drawing/2014/main" id="{E6CA27D0-D1F6-4794-8633-EDF467D14214}"/>
               </a:ext>
             </a:extLst>
           </p:cNvPr>
@@ -4868,7 +4868,7 @@
           <p:cNvPr id="16" name="pipe-text-4">
             <a:extLst xmlns:a="http://schemas.openxmlformats.org/drawingml/2006/main">
               <a:ext uri="{FF2B5EF4-FFF2-40B4-BE49-F238E27FC236}">
-                <a16:creationId xmlns:a16="http://schemas.microsoft.com/office/drawing/2014/main" id="{9AAA756D-D786-4F1D-9001-8C6A98472415}"/>
+                <a16:creationId xmlns:a16="http://schemas.microsoft.com/office/drawing/2014/main" id="{A3FEBE17-DC9B-4499-BF4B-25A605BDDBAA}"/>
               </a:ext>
             </a:extLst>
           </p:cNvPr>
@@ -4915,7 +4915,7 @@
           <p:cNvPr id="17" name="r-label">
             <a:extLst xmlns:a="http://schemas.openxmlformats.org/drawingml/2006/main">
               <a:ext uri="{FF2B5EF4-FFF2-40B4-BE49-F238E27FC236}">
-                <a16:creationId xmlns:a16="http://schemas.microsoft.com/office/drawing/2014/main" id="{3ED02E0A-BF20-46C9-A98F-E088D7CB3D2F}"/>
+                <a16:creationId xmlns:a16="http://schemas.microsoft.com/office/drawing/2014/main" id="{A2920661-053D-4A2E-A534-8B5B598EDD14}"/>
               </a:ext>
             </a:extLst>
           </p:cNvPr>
@@ -4960,7 +4960,7 @@
           <p:cNvPr id="18" name="r-formula">
             <a:extLst xmlns:a="http://schemas.openxmlformats.org/drawingml/2006/main">
               <a:ext uri="{FF2B5EF4-FFF2-40B4-BE49-F238E27FC236}">
-                <a16:creationId xmlns:a16="http://schemas.microsoft.com/office/drawing/2014/main" id="{39DDC7D1-D841-499B-9EC8-58330C4956FF}"/>
+                <a16:creationId xmlns:a16="http://schemas.microsoft.com/office/drawing/2014/main" id="{C47ADD89-073C-44E0-B0B2-E1A34DB17C59}"/>
               </a:ext>
             </a:extLst>
           </p:cNvPr>
@@ -5005,7 +5005,7 @@
           <p:cNvPr id="19" name="r-caveat">
             <a:extLst xmlns:a="http://schemas.openxmlformats.org/drawingml/2006/main">
               <a:ext uri="{FF2B5EF4-FFF2-40B4-BE49-F238E27FC236}">
-                <a16:creationId xmlns:a16="http://schemas.microsoft.com/office/drawing/2014/main" id="{2D09915A-50E3-4C12-862F-A98BC7D9629C}"/>
+                <a16:creationId xmlns:a16="http://schemas.microsoft.com/office/drawing/2014/main" id="{482134B7-4F64-489A-9CBB-3671E4C9D53B}"/>
               </a:ext>
             </a:extLst>
           </p:cNvPr>
@@ -5050,7 +5050,7 @@
           <p:cNvPr id="20" name="method-source">
             <a:extLst xmlns:a="http://schemas.openxmlformats.org/drawingml/2006/main">
               <a:ext uri="{FF2B5EF4-FFF2-40B4-BE49-F238E27FC236}">
-                <a16:creationId xmlns:a16="http://schemas.microsoft.com/office/drawing/2014/main" id="{C01E2176-EF49-4C35-9CA2-EF514C766A2F}"/>
+                <a16:creationId xmlns:a16="http://schemas.microsoft.com/office/drawing/2014/main" id="{91CA04EF-8DF7-4292-8DC8-1DAB1568C1DA}"/>
               </a:ext>
             </a:extLst>
           </p:cNvPr>
@@ -5095,7 +5095,7 @@
           <p:cNvPr id="21" name="page-number">
             <a:extLst xmlns:a="http://schemas.openxmlformats.org/drawingml/2006/main">
               <a:ext uri="{FF2B5EF4-FFF2-40B4-BE49-F238E27FC236}">
-                <a16:creationId xmlns:a16="http://schemas.microsoft.com/office/drawing/2014/main" id="{30FF5CA9-CD99-4691-8513-BF3CA1242026}"/>
+                <a16:creationId xmlns:a16="http://schemas.microsoft.com/office/drawing/2014/main" id="{CD08B345-5952-4797-8CD7-2FDABF7C968F}"/>
               </a:ext>
             </a:extLst>
           </p:cNvPr>
@@ -5138,7 +5138,7 @@
     </p:spTree>
     <p:extLst>
       <p:ext uri="{BB962C8B-B14F-4D97-AF65-F5344CB8AC3E}">
-        <p14:creationId xmlns:p14="http://schemas.microsoft.com/office/powerpoint/2010/main" val="515593474"/>
+        <p14:creationId xmlns:p14="http://schemas.microsoft.com/office/powerpoint/2010/main" val="882144997"/>
       </p:ext>
     </p:extLst>
   </p:cSld>
@@ -5169,7 +5169,7 @@
           <p:cNvPr id="13" name="slide-title">
             <a:extLst xmlns:a="http://schemas.openxmlformats.org/drawingml/2006/main">
               <a:ext uri="{FF2B5EF4-FFF2-40B4-BE49-F238E27FC236}">
-                <a16:creationId xmlns:a16="http://schemas.microsoft.com/office/drawing/2014/main" id="{D128A71D-89CF-4BB8-BD25-EEA9F7B8E9DF}"/>
+                <a16:creationId xmlns:a16="http://schemas.microsoft.com/office/drawing/2014/main" id="{93C923D8-9EF2-4900-8AA2-142BE3EC9E10}"/>
               </a:ext>
             </a:extLst>
           </p:cNvPr>
@@ -5214,7 +5214,7 @@
           <p:cNvPr id="2" name="proxy-label">
             <a:extLst xmlns:a="http://schemas.openxmlformats.org/drawingml/2006/main">
               <a:ext uri="{FF2B5EF4-FFF2-40B4-BE49-F238E27FC236}">
-                <a16:creationId xmlns:a16="http://schemas.microsoft.com/office/drawing/2014/main" id="{06FBA241-B376-4D16-8869-382B57898244}"/>
+                <a16:creationId xmlns:a16="http://schemas.microsoft.com/office/drawing/2014/main" id="{CB10ABD1-9A85-402D-A2A9-7BA734179720}"/>
               </a:ext>
             </a:extLst>
           </p:cNvPr>
@@ -5259,7 +5259,7 @@
           <p:cNvPr id="3" name="proxy-h">
             <a:extLst xmlns:a="http://schemas.openxmlformats.org/drawingml/2006/main">
               <a:ext uri="{FF2B5EF4-FFF2-40B4-BE49-F238E27FC236}">
-                <a16:creationId xmlns:a16="http://schemas.microsoft.com/office/drawing/2014/main" id="{EBDCB5DA-0DD4-44AD-A863-6B7462BCB1E1}"/>
+                <a16:creationId xmlns:a16="http://schemas.microsoft.com/office/drawing/2014/main" id="{3F5BD0F7-E73D-4C43-A86A-CE36FBED8D7F}"/>
               </a:ext>
             </a:extLst>
           </p:cNvPr>
@@ -5304,7 +5304,7 @@
           <p:cNvPr id="4" name="proxy-s">
             <a:extLst xmlns:a="http://schemas.openxmlformats.org/drawingml/2006/main">
               <a:ext uri="{FF2B5EF4-FFF2-40B4-BE49-F238E27FC236}">
-                <a16:creationId xmlns:a16="http://schemas.microsoft.com/office/drawing/2014/main" id="{2A8715B9-A524-4ADE-B773-511C213527C7}"/>
+                <a16:creationId xmlns:a16="http://schemas.microsoft.com/office/drawing/2014/main" id="{765516A3-7658-460E-A7EF-983CD368E976}"/>
               </a:ext>
             </a:extLst>
           </p:cNvPr>
@@ -5349,7 +5349,7 @@
           <p:cNvPr id="5" name="sum-square-callout">
             <a:extLst xmlns:a="http://schemas.openxmlformats.org/drawingml/2006/main">
               <a:ext uri="{FF2B5EF4-FFF2-40B4-BE49-F238E27FC236}">
-                <a16:creationId xmlns:a16="http://schemas.microsoft.com/office/drawing/2014/main" id="{D86B1E9B-BE04-418E-B797-F1520E02D5AE}"/>
+                <a16:creationId xmlns:a16="http://schemas.microsoft.com/office/drawing/2014/main" id="{3832915D-2DFF-4331-8E13-277DC754811B}"/>
               </a:ext>
             </a:extLst>
           </p:cNvPr>
@@ -5382,7 +5382,7 @@
           <p:cNvPr id="6" name="sum-square">
             <a:extLst xmlns:a="http://schemas.openxmlformats.org/drawingml/2006/main">
               <a:ext uri="{FF2B5EF4-FFF2-40B4-BE49-F238E27FC236}">
-                <a16:creationId xmlns:a16="http://schemas.microsoft.com/office/drawing/2014/main" id="{ADBDA8A8-EC71-4431-9B04-97CF5CA93F2E}"/>
+                <a16:creationId xmlns:a16="http://schemas.microsoft.com/office/drawing/2014/main" id="{0DE838E5-71A7-4AD6-AFB8-B09DB6C470FD}"/>
               </a:ext>
             </a:extLst>
           </p:cNvPr>
@@ -5427,7 +5427,7 @@
           <p:cNvPr id="7" name="proxy-method">
             <a:extLst xmlns:a="http://schemas.openxmlformats.org/drawingml/2006/main">
               <a:ext uri="{FF2B5EF4-FFF2-40B4-BE49-F238E27FC236}">
-                <a16:creationId xmlns:a16="http://schemas.microsoft.com/office/drawing/2014/main" id="{3804CCAF-10D7-4434-9F5C-34F1A1C3B52D}"/>
+                <a16:creationId xmlns:a16="http://schemas.microsoft.com/office/drawing/2014/main" id="{7821FF5F-570F-461C-83B4-5ADF0F7C01BD}"/>
               </a:ext>
             </a:extLst>
           </p:cNvPr>
@@ -5472,7 +5472,7 @@
           <p:cNvPr id="8" name="frame0-backing">
             <a:extLst xmlns:a="http://schemas.openxmlformats.org/drawingml/2006/main">
               <a:ext uri="{FF2B5EF4-FFF2-40B4-BE49-F238E27FC236}">
-                <a16:creationId xmlns:a16="http://schemas.microsoft.com/office/drawing/2014/main" id="{5A612D22-E0CF-4C99-ACEB-D43B1A3F6918}"/>
+                <a16:creationId xmlns:a16="http://schemas.microsoft.com/office/drawing/2014/main" id="{2BD3B2AF-C2EB-46AE-A3A2-BF18FA5A10DE}"/>
               </a:ext>
             </a:extLst>
           </p:cNvPr>
@@ -5509,7 +5509,7 @@
           <p:nvPr/>
         </p:nvPicPr>
         <p:blipFill>
-          <a:blip xmlns:r="http://schemas.openxmlformats.org/officeDocument/2006/relationships" xmlns:a="http://schemas.openxmlformats.org/drawingml/2006/main" r:embed="R23cc1bdaa752484b"/>
+          <a:blip xmlns:r="http://schemas.openxmlformats.org/officeDocument/2006/relationships" xmlns:a="http://schemas.openxmlformats.org/drawingml/2006/main" r:embed="Ra8a9ca275cc041c4"/>
           <a:stretch xmlns:a="http://schemas.openxmlformats.org/drawingml/2006/main"/>
         </p:blipFill>
         <p:spPr>
@@ -5527,7 +5527,7 @@
           <p:cNvPr id="10" name="weight-caption">
             <a:extLst xmlns:a="http://schemas.openxmlformats.org/drawingml/2006/main">
               <a:ext uri="{FF2B5EF4-FFF2-40B4-BE49-F238E27FC236}">
-                <a16:creationId xmlns:a16="http://schemas.microsoft.com/office/drawing/2014/main" id="{1CB54B1F-D255-464B-9F48-1274D342123F}"/>
+                <a16:creationId xmlns:a16="http://schemas.microsoft.com/office/drawing/2014/main" id="{D5D5E6F7-029B-4986-95CB-D13EDFBE4A6B}"/>
               </a:ext>
             </a:extLst>
           </p:cNvPr>
@@ -5572,7 +5572,7 @@
           <p:cNvPr id="11" name="method-source">
             <a:extLst xmlns:a="http://schemas.openxmlformats.org/drawingml/2006/main">
               <a:ext uri="{FF2B5EF4-FFF2-40B4-BE49-F238E27FC236}">
-                <a16:creationId xmlns:a16="http://schemas.microsoft.com/office/drawing/2014/main" id="{92BD18BF-0072-4E5F-85FC-0DF79818A7B0}"/>
+                <a16:creationId xmlns:a16="http://schemas.microsoft.com/office/drawing/2014/main" id="{E90F2471-36BF-4B73-A9A3-C16D4227EC15}"/>
               </a:ext>
             </a:extLst>
           </p:cNvPr>
@@ -5617,7 +5617,7 @@
           <p:cNvPr id="12" name="page-number">
             <a:extLst xmlns:a="http://schemas.openxmlformats.org/drawingml/2006/main">
               <a:ext uri="{FF2B5EF4-FFF2-40B4-BE49-F238E27FC236}">
-                <a16:creationId xmlns:a16="http://schemas.microsoft.com/office/drawing/2014/main" id="{A0A4CF8F-0738-4A79-8B35-08D7618D432F}"/>
+                <a16:creationId xmlns:a16="http://schemas.microsoft.com/office/drawing/2014/main" id="{D6A8B629-F15E-4380-A6B7-33DBAED75754}"/>
               </a:ext>
             </a:extLst>
           </p:cNvPr>
@@ -5660,7 +5660,7 @@
     </p:spTree>
     <p:extLst>
       <p:ext uri="{BB962C8B-B14F-4D97-AF65-F5344CB8AC3E}">
-        <p14:creationId xmlns:p14="http://schemas.microsoft.com/office/powerpoint/2010/main" val="641717882"/>
+        <p14:creationId xmlns:p14="http://schemas.microsoft.com/office/powerpoint/2010/main" val="1571168604"/>
       </p:ext>
     </p:extLst>
   </p:cSld>
@@ -5691,7 +5691,7 @@
           <p:cNvPr id="23" name="slide-title">
             <a:extLst xmlns:a="http://schemas.openxmlformats.org/drawingml/2006/main">
               <a:ext uri="{FF2B5EF4-FFF2-40B4-BE49-F238E27FC236}">
-                <a16:creationId xmlns:a16="http://schemas.microsoft.com/office/drawing/2014/main" id="{EF775F8A-B5B7-493C-92AF-8C8EAD41C97F}"/>
+                <a16:creationId xmlns:a16="http://schemas.microsoft.com/office/drawing/2014/main" id="{AC81FC88-D520-4C70-9EC4-D9F88C911342}"/>
               </a:ext>
             </a:extLst>
           </p:cNvPr>
@@ -5736,7 +5736,7 @@
           <p:cNvPr id="2" name="move-1">
             <a:extLst xmlns:a="http://schemas.openxmlformats.org/drawingml/2006/main">
               <a:ext uri="{FF2B5EF4-FFF2-40B4-BE49-F238E27FC236}">
-                <a16:creationId xmlns:a16="http://schemas.microsoft.com/office/drawing/2014/main" id="{4D06D47B-C224-42C6-B589-BDF342EE3B68}"/>
+                <a16:creationId xmlns:a16="http://schemas.microsoft.com/office/drawing/2014/main" id="{924DAF23-D2F3-4440-B65F-E1C4A39B0C4C}"/>
               </a:ext>
             </a:extLst>
           </p:cNvPr>
@@ -5769,7 +5769,7 @@
           <p:cNvPr id="3" name="move-2">
             <a:extLst xmlns:a="http://schemas.openxmlformats.org/drawingml/2006/main">
               <a:ext uri="{FF2B5EF4-FFF2-40B4-BE49-F238E27FC236}">
-                <a16:creationId xmlns:a16="http://schemas.microsoft.com/office/drawing/2014/main" id="{97CC24E2-E561-40CF-B1FE-4B843D82ADAC}"/>
+                <a16:creationId xmlns:a16="http://schemas.microsoft.com/office/drawing/2014/main" id="{508BE088-33D9-4AD6-AEDD-8847002C2C51}"/>
               </a:ext>
             </a:extLst>
           </p:cNvPr>
@@ -5802,7 +5802,7 @@
           <p:cNvPr id="4" name="move-3">
             <a:extLst xmlns:a="http://schemas.openxmlformats.org/drawingml/2006/main">
               <a:ext uri="{FF2B5EF4-FFF2-40B4-BE49-F238E27FC236}">
-                <a16:creationId xmlns:a16="http://schemas.microsoft.com/office/drawing/2014/main" id="{0F0C6DB0-D8F3-469C-B23F-7AEBB881F6EE}"/>
+                <a16:creationId xmlns:a16="http://schemas.microsoft.com/office/drawing/2014/main" id="{7E14F4B9-3A0A-4F7C-A52A-0A22665B7D02}"/>
               </a:ext>
             </a:extLst>
           </p:cNvPr>
@@ -5835,7 +5835,7 @@
           <p:cNvPr id="5" name="move-label-1">
             <a:extLst xmlns:a="http://schemas.openxmlformats.org/drawingml/2006/main">
               <a:ext uri="{FF2B5EF4-FFF2-40B4-BE49-F238E27FC236}">
-                <a16:creationId xmlns:a16="http://schemas.microsoft.com/office/drawing/2014/main" id="{E4DAAF6B-ED15-433D-A447-8FC65559D2B7}"/>
+                <a16:creationId xmlns:a16="http://schemas.microsoft.com/office/drawing/2014/main" id="{8DA4733E-64C8-4206-87EA-D6CB9EFB510C}"/>
               </a:ext>
             </a:extLst>
           </p:cNvPr>
@@ -5880,7 +5880,7 @@
           <p:cNvPr id="6" name="move-body-1">
             <a:extLst xmlns:a="http://schemas.openxmlformats.org/drawingml/2006/main">
               <a:ext uri="{FF2B5EF4-FFF2-40B4-BE49-F238E27FC236}">
-                <a16:creationId xmlns:a16="http://schemas.microsoft.com/office/drawing/2014/main" id="{EF0B15ED-5769-4D5C-86F8-4A63CA01A108}"/>
+                <a16:creationId xmlns:a16="http://schemas.microsoft.com/office/drawing/2014/main" id="{1C727DAE-3077-4D74-BEFC-46D72FD2482E}"/>
               </a:ext>
             </a:extLst>
           </p:cNvPr>
@@ -5925,7 +5925,7 @@
           <p:cNvPr id="7" name="move-label-2">
             <a:extLst xmlns:a="http://schemas.openxmlformats.org/drawingml/2006/main">
               <a:ext uri="{FF2B5EF4-FFF2-40B4-BE49-F238E27FC236}">
-                <a16:creationId xmlns:a16="http://schemas.microsoft.com/office/drawing/2014/main" id="{C040107F-EE8A-4034-BF9F-062E49D930D4}"/>
+                <a16:creationId xmlns:a16="http://schemas.microsoft.com/office/drawing/2014/main" id="{CA36DC54-3F1E-401E-B395-0E25DA83ECEB}"/>
               </a:ext>
             </a:extLst>
           </p:cNvPr>
@@ -5970,7 +5970,7 @@
           <p:cNvPr id="8" name="move-body-2">
             <a:extLst xmlns:a="http://schemas.openxmlformats.org/drawingml/2006/main">
               <a:ext uri="{FF2B5EF4-FFF2-40B4-BE49-F238E27FC236}">
-                <a16:creationId xmlns:a16="http://schemas.microsoft.com/office/drawing/2014/main" id="{B668F16D-C6CF-4F08-93F8-528E997CB274}"/>
+                <a16:creationId xmlns:a16="http://schemas.microsoft.com/office/drawing/2014/main" id="{9630FE81-56A4-412A-AFA4-9005BDB832ED}"/>
               </a:ext>
             </a:extLst>
           </p:cNvPr>
@@ -6015,7 +6015,7 @@
           <p:cNvPr id="9" name="move-label-3">
             <a:extLst xmlns:a="http://schemas.openxmlformats.org/drawingml/2006/main">
               <a:ext uri="{FF2B5EF4-FFF2-40B4-BE49-F238E27FC236}">
-                <a16:creationId xmlns:a16="http://schemas.microsoft.com/office/drawing/2014/main" id="{30BF3C9E-FA5D-449A-BEF5-F7A8DFAE4AE4}"/>
+                <a16:creationId xmlns:a16="http://schemas.microsoft.com/office/drawing/2014/main" id="{60E7E4FE-7919-42B4-A4A3-3F03782CDA89}"/>
               </a:ext>
             </a:extLst>
           </p:cNvPr>
@@ -6060,7 +6060,7 @@
           <p:cNvPr id="10" name="move-body-3">
             <a:extLst xmlns:a="http://schemas.openxmlformats.org/drawingml/2006/main">
               <a:ext uri="{FF2B5EF4-FFF2-40B4-BE49-F238E27FC236}">
-                <a16:creationId xmlns:a16="http://schemas.microsoft.com/office/drawing/2014/main" id="{3E0220DB-C383-414A-9797-0AD64C33EA1A}"/>
+                <a16:creationId xmlns:a16="http://schemas.microsoft.com/office/drawing/2014/main" id="{B9B9202C-DC79-43C9-9CB4-F17A5E4C6F61}"/>
               </a:ext>
             </a:extLst>
           </p:cNvPr>
@@ -6105,7 +6105,7 @@
           <p:cNvPr id="11" name="dfs-label">
             <a:extLst xmlns:a="http://schemas.openxmlformats.org/drawingml/2006/main">
               <a:ext uri="{FF2B5EF4-FFF2-40B4-BE49-F238E27FC236}">
-                <a16:creationId xmlns:a16="http://schemas.microsoft.com/office/drawing/2014/main" id="{01149414-9DDE-4931-9416-FE0A6D362781}"/>
+                <a16:creationId xmlns:a16="http://schemas.microsoft.com/office/drawing/2014/main" id="{AF64C2F6-313B-46EB-B636-46EB22A6BBAB}"/>
               </a:ext>
             </a:extLst>
           </p:cNvPr>
@@ -6150,7 +6150,7 @@
           <p:cNvPr id="12" name="dfs-formula">
             <a:extLst xmlns:a="http://schemas.openxmlformats.org/drawingml/2006/main">
               <a:ext uri="{FF2B5EF4-FFF2-40B4-BE49-F238E27FC236}">
-                <a16:creationId xmlns:a16="http://schemas.microsoft.com/office/drawing/2014/main" id="{C573EFF0-17DF-415F-A4A8-04284AE21631}"/>
+                <a16:creationId xmlns:a16="http://schemas.microsoft.com/office/drawing/2014/main" id="{F3D7395C-DD43-4FEB-942F-45B34AC408F0}"/>
               </a:ext>
             </a:extLst>
           </p:cNvPr>
@@ -6195,7 +6195,7 @@
           <p:cNvPr id="13" name="pilot-stat">
             <a:extLst xmlns:a="http://schemas.openxmlformats.org/drawingml/2006/main">
               <a:ext uri="{FF2B5EF4-FFF2-40B4-BE49-F238E27FC236}">
-                <a16:creationId xmlns:a16="http://schemas.microsoft.com/office/drawing/2014/main" id="{82F5365C-F18A-4D4F-A97C-0382B39A5B89}"/>
+                <a16:creationId xmlns:a16="http://schemas.microsoft.com/office/drawing/2014/main" id="{75D1F68B-ACAA-42C9-8EB2-4A958700B22D}"/>
               </a:ext>
             </a:extLst>
           </p:cNvPr>
@@ -6240,7 +6240,7 @@
           <p:cNvPr id="14" name="pilot-label">
             <a:extLst xmlns:a="http://schemas.openxmlformats.org/drawingml/2006/main">
               <a:ext uri="{FF2B5EF4-FFF2-40B4-BE49-F238E27FC236}">
-                <a16:creationId xmlns:a16="http://schemas.microsoft.com/office/drawing/2014/main" id="{57300EB0-7C6C-40BD-93B9-85F0BBE9C8A6}"/>
+                <a16:creationId xmlns:a16="http://schemas.microsoft.com/office/drawing/2014/main" id="{FEF7B3D2-E79C-44C8-93B6-D6A889A8760B}"/>
               </a:ext>
             </a:extLst>
           </p:cNvPr>
@@ -6285,7 +6285,7 @@
           <p:cNvPr id="15" name="eval-stat">
             <a:extLst xmlns:a="http://schemas.openxmlformats.org/drawingml/2006/main">
               <a:ext uri="{FF2B5EF4-FFF2-40B4-BE49-F238E27FC236}">
-                <a16:creationId xmlns:a16="http://schemas.microsoft.com/office/drawing/2014/main" id="{98EC1FD1-744C-4FB0-8AB3-86CB238B01BC}"/>
+                <a16:creationId xmlns:a16="http://schemas.microsoft.com/office/drawing/2014/main" id="{08113176-C679-4545-810B-22B39F747166}"/>
               </a:ext>
             </a:extLst>
           </p:cNvPr>
@@ -6330,7 +6330,7 @@
           <p:cNvPr id="16" name="eval-label">
             <a:extLst xmlns:a="http://schemas.openxmlformats.org/drawingml/2006/main">
               <a:ext uri="{FF2B5EF4-FFF2-40B4-BE49-F238E27FC236}">
-                <a16:creationId xmlns:a16="http://schemas.microsoft.com/office/drawing/2014/main" id="{4F54B157-DAFA-419F-8395-72BF6B334C22}"/>
+                <a16:creationId xmlns:a16="http://schemas.microsoft.com/office/drawing/2014/main" id="{8652F71E-6C5B-4531-9D39-A15629C270AC}"/>
               </a:ext>
             </a:extLst>
           </p:cNvPr>
@@ -6375,7 +6375,7 @@
           <p:cNvPr id="17" name="accept-stat">
             <a:extLst xmlns:a="http://schemas.openxmlformats.org/drawingml/2006/main">
               <a:ext uri="{FF2B5EF4-FFF2-40B4-BE49-F238E27FC236}">
-                <a16:creationId xmlns:a16="http://schemas.microsoft.com/office/drawing/2014/main" id="{43F985B2-169A-489B-BB97-ACA178F7B4D7}"/>
+                <a16:creationId xmlns:a16="http://schemas.microsoft.com/office/drawing/2014/main" id="{5E6AB31B-9DEF-43D7-B0D2-FC58574EA268}"/>
               </a:ext>
             </a:extLst>
           </p:cNvPr>
@@ -6420,7 +6420,7 @@
           <p:cNvPr id="18" name="accept-label">
             <a:extLst xmlns:a="http://schemas.openxmlformats.org/drawingml/2006/main">
               <a:ext uri="{FF2B5EF4-FFF2-40B4-BE49-F238E27FC236}">
-                <a16:creationId xmlns:a16="http://schemas.microsoft.com/office/drawing/2014/main" id="{3C1E5F0A-BCA7-49F2-BE5D-B856B7DFDDCD}"/>
+                <a16:creationId xmlns:a16="http://schemas.microsoft.com/office/drawing/2014/main" id="{02285E23-8A80-4F3B-9854-E0B3836C4520}"/>
               </a:ext>
             </a:extLst>
           </p:cNvPr>
@@ -6465,7 +6465,7 @@
           <p:cNvPr id="19" name="not-posterior">
             <a:extLst xmlns:a="http://schemas.openxmlformats.org/drawingml/2006/main">
               <a:ext uri="{FF2B5EF4-FFF2-40B4-BE49-F238E27FC236}">
-                <a16:creationId xmlns:a16="http://schemas.microsoft.com/office/drawing/2014/main" id="{54170676-D458-439E-8867-7DBEAF364811}"/>
+                <a16:creationId xmlns:a16="http://schemas.microsoft.com/office/drawing/2014/main" id="{FE494E60-38DD-4938-A236-BDA6D5100122}"/>
               </a:ext>
             </a:extLst>
           </p:cNvPr>
@@ -6498,7 +6498,7 @@
           <p:cNvPr id="20" name="not-posterior-text">
             <a:extLst xmlns:a="http://schemas.openxmlformats.org/drawingml/2006/main">
               <a:ext uri="{FF2B5EF4-FFF2-40B4-BE49-F238E27FC236}">
-                <a16:creationId xmlns:a16="http://schemas.microsoft.com/office/drawing/2014/main" id="{F5FCB401-3774-4A1A-A82C-AB6B2EB2EDEE}"/>
+                <a16:creationId xmlns:a16="http://schemas.microsoft.com/office/drawing/2014/main" id="{7BE7ACD4-B803-44CA-8FF0-D52B1DF26677}"/>
               </a:ext>
             </a:extLst>
           </p:cNvPr>
@@ -6543,7 +6543,7 @@
           <p:cNvPr id="21" name="method-source">
             <a:extLst xmlns:a="http://schemas.openxmlformats.org/drawingml/2006/main">
               <a:ext uri="{FF2B5EF4-FFF2-40B4-BE49-F238E27FC236}">
-                <a16:creationId xmlns:a16="http://schemas.microsoft.com/office/drawing/2014/main" id="{E802A12C-5A21-4E69-855D-B6635ABFE058}"/>
+                <a16:creationId xmlns:a16="http://schemas.microsoft.com/office/drawing/2014/main" id="{2AAE927D-A45A-4C2E-AB4C-2BB4CA25A762}"/>
               </a:ext>
             </a:extLst>
           </p:cNvPr>
@@ -6588,7 +6588,7 @@
           <p:cNvPr id="22" name="page-number">
             <a:extLst xmlns:a="http://schemas.openxmlformats.org/drawingml/2006/main">
               <a:ext uri="{FF2B5EF4-FFF2-40B4-BE49-F238E27FC236}">
-                <a16:creationId xmlns:a16="http://schemas.microsoft.com/office/drawing/2014/main" id="{71D9651C-B88B-4076-8BAB-2B2D1FDA90F1}"/>
+                <a16:creationId xmlns:a16="http://schemas.microsoft.com/office/drawing/2014/main" id="{95F7C1C1-E22C-4AD1-9C97-19FC051C1DA0}"/>
               </a:ext>
             </a:extLst>
           </p:cNvPr>
@@ -6631,7 +6631,7 @@
     </p:spTree>
     <p:extLst>
       <p:ext uri="{BB962C8B-B14F-4D97-AF65-F5344CB8AC3E}">
-        <p14:creationId xmlns:p14="http://schemas.microsoft.com/office/powerpoint/2010/main" val="1700049338"/>
+        <p14:creationId xmlns:p14="http://schemas.microsoft.com/office/powerpoint/2010/main" val="1137764437"/>
       </p:ext>
     </p:extLst>
   </p:cSld>
@@ -6662,7 +6662,7 @@
           <p:cNvPr id="12" name="slide-title">
             <a:extLst xmlns:a="http://schemas.openxmlformats.org/drawingml/2006/main">
               <a:ext uri="{FF2B5EF4-FFF2-40B4-BE49-F238E27FC236}">
-                <a16:creationId xmlns:a16="http://schemas.microsoft.com/office/drawing/2014/main" id="{E432EC82-49E8-40F7-A9DB-C5603BAF9FB9}"/>
+                <a16:creationId xmlns:a16="http://schemas.microsoft.com/office/drawing/2014/main" id="{AEECDFB2-D974-408F-972A-323ED971D2E5}"/>
               </a:ext>
             </a:extLst>
           </p:cNvPr>
@@ -6711,7 +6711,7 @@
           <p:nvPr/>
         </p:nvPicPr>
         <p:blipFill>
-          <a:blip xmlns:r="http://schemas.openxmlformats.org/officeDocument/2006/relationships" xmlns:a="http://schemas.openxmlformats.org/drawingml/2006/main" r:embed="R5fea29afe40b487c"/>
+          <a:blip xmlns:r="http://schemas.openxmlformats.org/officeDocument/2006/relationships" xmlns:a="http://schemas.openxmlformats.org/drawingml/2006/main" r:embed="Rb6850167b17a459d"/>
           <a:stretch xmlns:a="http://schemas.openxmlformats.org/drawingml/2006/main"/>
         </p:blipFill>
         <p:spPr>
@@ -6751,7 +6751,7 @@
           <p:cNvPr id="4" name="combined-result">
             <a:extLst xmlns:a="http://schemas.openxmlformats.org/drawingml/2006/main">
               <a:ext uri="{FF2B5EF4-FFF2-40B4-BE49-F238E27FC236}">
-                <a16:creationId xmlns:a16="http://schemas.microsoft.com/office/drawing/2014/main" id="{8B38D4FE-8544-40DA-8E7B-85063E4D0C4B}"/>
+                <a16:creationId xmlns:a16="http://schemas.microsoft.com/office/drawing/2014/main" id="{0451DB25-0567-4705-83BC-F8AF550BA996}"/>
               </a:ext>
             </a:extLst>
           </p:cNvPr>
@@ -6796,7 +6796,7 @@
           <p:cNvPr id="5" name="combined-label">
             <a:extLst xmlns:a="http://schemas.openxmlformats.org/drawingml/2006/main">
               <a:ext uri="{FF2B5EF4-FFF2-40B4-BE49-F238E27FC236}">
-                <a16:creationId xmlns:a16="http://schemas.microsoft.com/office/drawing/2014/main" id="{2744C8A6-1B0A-4615-903B-D64EB0FF87EB}"/>
+                <a16:creationId xmlns:a16="http://schemas.microsoft.com/office/drawing/2014/main" id="{DCCD842A-5446-410B-86B1-06144407724B}"/>
               </a:ext>
             </a:extLst>
           </p:cNvPr>
@@ -6841,7 +6841,7 @@
           <p:cNvPr id="6" name="mhd-result">
             <a:extLst xmlns:a="http://schemas.openxmlformats.org/drawingml/2006/main">
               <a:ext uri="{FF2B5EF4-FFF2-40B4-BE49-F238E27FC236}">
-                <a16:creationId xmlns:a16="http://schemas.microsoft.com/office/drawing/2014/main" id="{1F8306EC-C04B-47D7-8200-32843B32BC19}"/>
+                <a16:creationId xmlns:a16="http://schemas.microsoft.com/office/drawing/2014/main" id="{B9155A8A-A4B1-46A5-A2BB-10E060E05553}"/>
               </a:ext>
             </a:extLst>
           </p:cNvPr>
@@ -6886,7 +6886,7 @@
           <p:cNvPr id="7" name="mhd-label">
             <a:extLst xmlns:a="http://schemas.openxmlformats.org/drawingml/2006/main">
               <a:ext uri="{FF2B5EF4-FFF2-40B4-BE49-F238E27FC236}">
-                <a16:creationId xmlns:a16="http://schemas.microsoft.com/office/drawing/2014/main" id="{8E59493B-BD8A-4A24-ABE6-364210D46567}"/>
+                <a16:creationId xmlns:a16="http://schemas.microsoft.com/office/drawing/2014/main" id="{987AB2F0-9A5F-46CC-89AA-468EBEAFDA02}"/>
               </a:ext>
             </a:extLst>
           </p:cNvPr>
@@ -6931,7 +6931,7 @@
           <p:cNvPr id="8" name="tac-result">
             <a:extLst xmlns:a="http://schemas.openxmlformats.org/drawingml/2006/main">
               <a:ext uri="{FF2B5EF4-FFF2-40B4-BE49-F238E27FC236}">
-                <a16:creationId xmlns:a16="http://schemas.microsoft.com/office/drawing/2014/main" id="{F33D4ABA-F4B4-412F-B25E-3716C9E9D040}"/>
+                <a16:creationId xmlns:a16="http://schemas.microsoft.com/office/drawing/2014/main" id="{C572F45B-35B3-48C8-8DDB-B541A6A0DBF8}"/>
               </a:ext>
             </a:extLst>
           </p:cNvPr>
@@ -6976,7 +6976,7 @@
           <p:cNvPr id="9" name="tac-label">
             <a:extLst xmlns:a="http://schemas.openxmlformats.org/drawingml/2006/main">
               <a:ext uri="{FF2B5EF4-FFF2-40B4-BE49-F238E27FC236}">
-                <a16:creationId xmlns:a16="http://schemas.microsoft.com/office/drawing/2014/main" id="{C7839691-8856-4A4A-874D-188E3B1B0B39}"/>
+                <a16:creationId xmlns:a16="http://schemas.microsoft.com/office/drawing/2014/main" id="{926A441D-00A9-40BF-A9DB-918BC1B81D5B}"/>
               </a:ext>
             </a:extLst>
           </p:cNvPr>
@@ -7021,7 +7021,7 @@
           <p:cNvPr id="10" name="method-source">
             <a:extLst xmlns:a="http://schemas.openxmlformats.org/drawingml/2006/main">
               <a:ext uri="{FF2B5EF4-FFF2-40B4-BE49-F238E27FC236}">
-                <a16:creationId xmlns:a16="http://schemas.microsoft.com/office/drawing/2014/main" id="{0AA688FC-DA89-418D-8CE0-5B42491F90B0}"/>
+                <a16:creationId xmlns:a16="http://schemas.microsoft.com/office/drawing/2014/main" id="{2C95A5D3-1CC2-4C63-9677-A6839D8F4E66}"/>
               </a:ext>
             </a:extLst>
           </p:cNvPr>
@@ -7066,7 +7066,7 @@
           <p:cNvPr id="11" name="page-number">
             <a:extLst xmlns:a="http://schemas.openxmlformats.org/drawingml/2006/main">
               <a:ext uri="{FF2B5EF4-FFF2-40B4-BE49-F238E27FC236}">
-                <a16:creationId xmlns:a16="http://schemas.microsoft.com/office/drawing/2014/main" id="{38DB2824-95E8-479B-B250-3D197098DD11}"/>
+                <a16:creationId xmlns:a16="http://schemas.microsoft.com/office/drawing/2014/main" id="{DC111F1B-1B27-4FBC-9CDC-3FB682BB00F7}"/>
               </a:ext>
             </a:extLst>
           </p:cNvPr>
@@ -7109,7 +7109,7 @@
     </p:spTree>
     <p:extLst>
       <p:ext uri="{BB962C8B-B14F-4D97-AF65-F5344CB8AC3E}">
-        <p14:creationId xmlns:p14="http://schemas.microsoft.com/office/powerpoint/2010/main" val="934638313"/>
+        <p14:creationId xmlns:p14="http://schemas.microsoft.com/office/powerpoint/2010/main" val="1479852683"/>
       </p:ext>
     </p:extLst>
   </p:cSld>
@@ -7137,10 +7137,10 @@
       </p:grpSpPr>
       <p:sp>
         <p:nvSpPr>
-          <p:cNvPr id="18" name="slide-title">
-            <a:extLst xmlns:a="http://schemas.openxmlformats.org/drawingml/2006/main">
-              <a:ext uri="{FF2B5EF4-FFF2-40B4-BE49-F238E27FC236}">
-                <a16:creationId xmlns:a16="http://schemas.microsoft.com/office/drawing/2014/main" id="{64CE55D4-37E1-44C6-98C8-C498423D6613}"/>
+          <p:cNvPr id="19" name="slide-title">
+            <a:extLst xmlns:a="http://schemas.openxmlformats.org/drawingml/2006/main">
+              <a:ext uri="{FF2B5EF4-FFF2-40B4-BE49-F238E27FC236}">
+                <a16:creationId xmlns:a16="http://schemas.microsoft.com/office/drawing/2014/main" id="{9CA4EAE6-1CF9-4A3D-B25F-8E51ED811FE3}"/>
               </a:ext>
             </a:extLst>
           </p:cNvPr>
@@ -7182,14 +7182,14 @@
       </p:sp>
       <p:pic>
         <p:nvPicPr>
-          <p:cNvPr id="19" name="variable-k-summary"/>
+          <p:cNvPr id="20" name="variable-k-summary"/>
           <p:cNvPicPr>
             <a:picLocks xmlns:a="http://schemas.openxmlformats.org/drawingml/2006/main" noChangeAspect="1"/>
           </p:cNvPicPr>
           <p:nvPr/>
         </p:nvPicPr>
         <p:blipFill>
-          <a:blip xmlns:r="http://schemas.openxmlformats.org/officeDocument/2006/relationships" xmlns:a="http://schemas.openxmlformats.org/drawingml/2006/main" r:embed="Rbee806d978074548"/>
+          <a:blip xmlns:r="http://schemas.openxmlformats.org/officeDocument/2006/relationships" xmlns:a="http://schemas.openxmlformats.org/drawingml/2006/main" r:embed="Ra3b9d4e26fb847b5"/>
           <a:stretch xmlns:a="http://schemas.openxmlformats.org/drawingml/2006/main"/>
         </p:blipFill>
         <p:spPr>
@@ -7207,7 +7207,7 @@
           <p:cNvPr id="3" name="variable-k-label">
             <a:extLst xmlns:a="http://schemas.openxmlformats.org/drawingml/2006/main">
               <a:ext uri="{FF2B5EF4-FFF2-40B4-BE49-F238E27FC236}">
-                <a16:creationId xmlns:a16="http://schemas.microsoft.com/office/drawing/2014/main" id="{BD5EA01B-AEBA-44D8-9EF8-580665A48D7D}"/>
+                <a16:creationId xmlns:a16="http://schemas.microsoft.com/office/drawing/2014/main" id="{7EDCA595-EAB9-46D1-A32C-408B7A44DF2E}"/>
               </a:ext>
             </a:extLst>
           </p:cNvPr>
@@ -7219,7 +7219,7 @@
         <p:spPr>
           <a:xfrm xmlns:a="http://schemas.openxmlformats.org/drawingml/2006/main">
             <a:off x="7600950" y="1200150"/>
-            <a:ext cx="2857500" cy="228600"/>
+            <a:ext cx="3238500" cy="228600"/>
           </a:xfrm>
           <a:prstGeom xmlns:a="http://schemas.openxmlformats.org/drawingml/2006/main" prst="rect">
             <a:avLst/>
@@ -7242,7 +7242,7 @@
               </a:defRPr>
             </a:pPr>
             <a:r>
-              <a:t>FULL-WEEK SCALE-UP</a:t>
+              <a:t>FULL-WEEK LONGER RUN</a:t>
             </a:r>
           </a:p>
         </p:txBody>
@@ -7252,19 +7252,19 @@
           <p:cNvPr id="4" name="variable-k-change">
             <a:extLst xmlns:a="http://schemas.openxmlformats.org/drawingml/2006/main">
               <a:ext uri="{FF2B5EF4-FFF2-40B4-BE49-F238E27FC236}">
-                <a16:creationId xmlns:a16="http://schemas.microsoft.com/office/drawing/2014/main" id="{4292E2B0-BB76-4CF0-BE8C-51DECFA003CF}"/>
-              </a:ext>
-            </a:extLst>
-          </p:cNvPr>
-          <p:cNvSpPr>
-            <a:spLocks xmlns:a="http://schemas.openxmlformats.org/drawingml/2006/main" noGrp="1"/>
-          </p:cNvSpPr>
-          <p:nvPr/>
-        </p:nvSpPr>
-        <p:spPr>
-          <a:xfrm xmlns:a="http://schemas.openxmlformats.org/drawingml/2006/main">
-            <a:off x="7600950" y="1609725"/>
-            <a:ext cx="3810000" cy="495300"/>
+                <a16:creationId xmlns:a16="http://schemas.microsoft.com/office/drawing/2014/main" id="{EBBA8CE8-10CE-4BBC-A87E-FF676B159482}"/>
+              </a:ext>
+            </a:extLst>
+          </p:cNvPr>
+          <p:cNvSpPr>
+            <a:spLocks xmlns:a="http://schemas.openxmlformats.org/drawingml/2006/main" noGrp="1"/>
+          </p:cNvSpPr>
+          <p:nvPr/>
+        </p:nvSpPr>
+        <p:spPr>
+          <a:xfrm xmlns:a="http://schemas.openxmlformats.org/drawingml/2006/main">
+            <a:off x="7600950" y="1571625"/>
+            <a:ext cx="3810000" cy="476250"/>
           </a:xfrm>
           <a:prstGeom xmlns:a="http://schemas.openxmlformats.org/drawingml/2006/main" prst="rect">
             <a:avLst/>
@@ -7297,32 +7297,32 @@
           <p:cNvPr id="5" name="variable-k-dfs">
             <a:extLst xmlns:a="http://schemas.openxmlformats.org/drawingml/2006/main">
               <a:ext uri="{FF2B5EF4-FFF2-40B4-BE49-F238E27FC236}">
-                <a16:creationId xmlns:a16="http://schemas.microsoft.com/office/drawing/2014/main" id="{D67857AC-E78E-4748-BEDC-8B6085090248}"/>
-              </a:ext>
-            </a:extLst>
-          </p:cNvPr>
-          <p:cNvSpPr>
-            <a:spLocks xmlns:a="http://schemas.openxmlformats.org/drawingml/2006/main" noGrp="1"/>
-          </p:cNvSpPr>
-          <p:nvPr/>
-        </p:nvSpPr>
-        <p:spPr>
-          <a:xfrm xmlns:a="http://schemas.openxmlformats.org/drawingml/2006/main">
-            <a:off x="7600950" y="2133600"/>
-            <a:ext cx="3810000" cy="495300"/>
-          </a:xfrm>
-          <a:prstGeom xmlns:a="http://schemas.openxmlformats.org/drawingml/2006/main" prst="rect">
-            <a:avLst/>
-          </a:prstGeom>
-        </p:spPr>
-        <p:txBody>
-          <a:bodyPr xmlns:a="http://schemas.openxmlformats.org/drawingml/2006/main" wrap="square" lIns="0" tIns="0" rIns="0" bIns="0" anchor="t">
-            <a:noAutofit/>
-          </a:bodyPr>
-          <a:lstStyle xmlns:a="http://schemas.openxmlformats.org/drawingml/2006/main"/>
-          <a:p xmlns:a="http://schemas.openxmlformats.org/drawingml/2006/main">
-            <a:pPr algn="l">
-              <a:defRPr sz="2025" b="1">
+                <a16:creationId xmlns:a16="http://schemas.microsoft.com/office/drawing/2014/main" id="{617D0785-6F78-4444-B19F-A33B21BA2195}"/>
+              </a:ext>
+            </a:extLst>
+          </p:cNvPr>
+          <p:cNvSpPr>
+            <a:spLocks xmlns:a="http://schemas.openxmlformats.org/drawingml/2006/main" noGrp="1"/>
+          </p:cNvSpPr>
+          <p:nvPr/>
+        </p:nvSpPr>
+        <p:spPr>
+          <a:xfrm xmlns:a="http://schemas.openxmlformats.org/drawingml/2006/main">
+            <a:off x="7600950" y="2105025"/>
+            <a:ext cx="3810000" cy="409575"/>
+          </a:xfrm>
+          <a:prstGeom xmlns:a="http://schemas.openxmlformats.org/drawingml/2006/main" prst="rect">
+            <a:avLst/>
+          </a:prstGeom>
+        </p:spPr>
+        <p:txBody>
+          <a:bodyPr xmlns:a="http://schemas.openxmlformats.org/drawingml/2006/main" wrap="square" lIns="0" tIns="0" rIns="0" bIns="0" anchor="t">
+            <a:noAutofit/>
+          </a:bodyPr>
+          <a:lstStyle xmlns:a="http://schemas.openxmlformats.org/drawingml/2006/main"/>
+          <a:p xmlns:a="http://schemas.openxmlformats.org/drawingml/2006/main">
+            <a:pPr algn="l">
+              <a:defRPr sz="2325" b="1">
                 <a:solidFill>
                   <a:srgbClr val="0B0D0F"/>
                 </a:solidFill>
@@ -7332,7 +7332,7 @@
               </a:defRPr>
             </a:pPr>
             <a:r>
-              <a:t>165 MHD + 168 TAC</a:t>
+              <a:t>K 24 → 25</a:t>
             </a:r>
           </a:p>
         </p:txBody>
@@ -7342,19 +7342,64 @@
           <p:cNvPr id="6" name="variable-k-config">
             <a:extLst xmlns:a="http://schemas.openxmlformats.org/drawingml/2006/main">
               <a:ext uri="{FF2B5EF4-FFF2-40B4-BE49-F238E27FC236}">
-                <a16:creationId xmlns:a16="http://schemas.microsoft.com/office/drawing/2014/main" id="{13F05287-7E85-4612-96B3-57635AAC7143}"/>
-              </a:ext>
-            </a:extLst>
-          </p:cNvPr>
-          <p:cNvSpPr>
-            <a:spLocks xmlns:a="http://schemas.openxmlformats.org/drawingml/2006/main" noGrp="1"/>
-          </p:cNvSpPr>
-          <p:nvPr/>
-        </p:nvSpPr>
-        <p:spPr>
-          <a:xfrm xmlns:a="http://schemas.openxmlformats.org/drawingml/2006/main">
-            <a:off x="7600950" y="2714625"/>
-            <a:ext cx="3810000" cy="1304925"/>
+                <a16:creationId xmlns:a16="http://schemas.microsoft.com/office/drawing/2014/main" id="{56BC1893-E8B4-4ED7-A321-AF6750C8FA27}"/>
+              </a:ext>
+            </a:extLst>
+          </p:cNvPr>
+          <p:cNvSpPr>
+            <a:spLocks xmlns:a="http://schemas.openxmlformats.org/drawingml/2006/main" noGrp="1"/>
+          </p:cNvSpPr>
+          <p:nvPr/>
+        </p:nvSpPr>
+        <p:spPr>
+          <a:xfrm xmlns:a="http://schemas.openxmlformats.org/drawingml/2006/main">
+            <a:off x="7600950" y="2581275"/>
+            <a:ext cx="3810000" cy="381000"/>
+          </a:xfrm>
+          <a:prstGeom xmlns:a="http://schemas.openxmlformats.org/drawingml/2006/main" prst="rect">
+            <a:avLst/>
+          </a:prstGeom>
+        </p:spPr>
+        <p:txBody>
+          <a:bodyPr xmlns:a="http://schemas.openxmlformats.org/drawingml/2006/main" wrap="square" lIns="0" tIns="0" rIns="0" bIns="0" anchor="t">
+            <a:noAutofit/>
+          </a:bodyPr>
+          <a:lstStyle xmlns:a="http://schemas.openxmlformats.org/drawingml/2006/main"/>
+          <a:p xmlns:a="http://schemas.openxmlformats.org/drawingml/2006/main">
+            <a:pPr algn="l">
+              <a:defRPr sz="1800" b="1">
+                <a:solidFill>
+                  <a:srgbClr val="0B0D0F"/>
+                </a:solidFill>
+                <a:latin typeface="Helvetica Neue"/>
+                <a:ea typeface="Helvetica Neue"/>
+                <a:cs typeface="Helvetica Neue"/>
+              </a:defRPr>
+            </a:pPr>
+            <a:r>
+              <a:t>DFS 5.878766 → 5.926013</a:t>
+            </a:r>
+          </a:p>
+        </p:txBody>
+      </p:sp>
+      <p:sp>
+        <p:nvSpPr>
+          <p:cNvPr id="7" name="variable-k-run-stats">
+            <a:extLst xmlns:a="http://schemas.openxmlformats.org/drawingml/2006/main">
+              <a:ext uri="{FF2B5EF4-FFF2-40B4-BE49-F238E27FC236}">
+                <a16:creationId xmlns:a16="http://schemas.microsoft.com/office/drawing/2014/main" id="{F8A8D4E7-1E29-4CD6-AF31-5FCFF12A195E}"/>
+              </a:ext>
+            </a:extLst>
+          </p:cNvPr>
+          <p:cNvSpPr>
+            <a:spLocks xmlns:a="http://schemas.openxmlformats.org/drawingml/2006/main" noGrp="1"/>
+          </p:cNvSpPr>
+          <p:nvPr/>
+        </p:nvSpPr>
+        <p:spPr>
+          <a:xfrm xmlns:a="http://schemas.openxmlformats.org/drawingml/2006/main">
+            <a:off x="7600950" y="3133725"/>
+            <a:ext cx="3810000" cy="609600"/>
           </a:xfrm>
           <a:prstGeom xmlns:a="http://schemas.openxmlformats.org/drawingml/2006/main" prst="rect">
             <a:avLst/>
@@ -7377,20 +7422,18 @@
               </a:defRPr>
             </a:pPr>
             <a:r>
-              <a:t>G: 333×293×391 → 333×37×49
-No missing-hour imputation
-600 evaluations · 366 accepted
-≈1 s excluding rendering</a:t>
-            </a:r>
-          </a:p>
-        </p:txBody>
-      </p:sp>
-      <p:sp>
-        <p:nvSpPr>
-          <p:cNvPr id="7" name="utility-formula-box">
-            <a:extLst xmlns:a="http://schemas.openxmlformats.org/drawingml/2006/main">
-              <a:ext uri="{FF2B5EF4-FFF2-40B4-BE49-F238E27FC236}">
-                <a16:creationId xmlns:a16="http://schemas.microsoft.com/office/drawing/2014/main" id="{44681E7F-27CA-476D-A8E8-1EBD2B615ECF}"/>
+              <a:t>2,000 evaluations · 927 accepted
+2.36 s excluding rendering</a:t>
+            </a:r>
+          </a:p>
+        </p:txBody>
+      </p:sp>
+      <p:sp>
+        <p:nvSpPr>
+          <p:cNvPr id="8" name="utility-formula-box">
+            <a:extLst xmlns:a="http://schemas.openxmlformats.org/drawingml/2006/main">
+              <a:ext uri="{FF2B5EF4-FFF2-40B4-BE49-F238E27FC236}">
+                <a16:creationId xmlns:a16="http://schemas.microsoft.com/office/drawing/2014/main" id="{A0415801-018B-49E9-A9A7-F351A894D725}"/>
               </a:ext>
             </a:extLst>
           </p:cNvPr>
@@ -7402,7 +7445,7 @@
         <p:spPr>
           <a:xfrm xmlns:a="http://schemas.openxmlformats.org/drawingml/2006/main">
             <a:off x="390525" y="4324350"/>
-            <a:ext cx="4514850" cy="714375"/>
+            <a:ext cx="4095750" cy="723900"/>
           </a:xfrm>
           <a:prstGeom xmlns:a="http://schemas.openxmlformats.org/drawingml/2006/main" prst="rect">
             <a:avLst/>
@@ -7420,22 +7463,22 @@
       </p:sp>
       <p:sp>
         <p:nvSpPr>
-          <p:cNvPr id="8" name="utility-formula">
-            <a:extLst xmlns:a="http://schemas.openxmlformats.org/drawingml/2006/main">
-              <a:ext uri="{FF2B5EF4-FFF2-40B4-BE49-F238E27FC236}">
-                <a16:creationId xmlns:a16="http://schemas.microsoft.com/office/drawing/2014/main" id="{2A7E31AB-8FA9-4AB2-80A4-68DF9EADC863}"/>
-              </a:ext>
-            </a:extLst>
-          </p:cNvPr>
-          <p:cNvSpPr>
-            <a:spLocks xmlns:a="http://schemas.openxmlformats.org/drawingml/2006/main" noGrp="1"/>
-          </p:cNvSpPr>
-          <p:nvPr/>
-        </p:nvSpPr>
-        <p:spPr>
-          <a:xfrm xmlns:a="http://schemas.openxmlformats.org/drawingml/2006/main">
-            <a:off x="581025" y="4533900"/>
-            <a:ext cx="4133850" cy="323850"/>
+          <p:cNvPr id="9" name="utility-formula">
+            <a:extLst xmlns:a="http://schemas.openxmlformats.org/drawingml/2006/main">
+              <a:ext uri="{FF2B5EF4-FFF2-40B4-BE49-F238E27FC236}">
+                <a16:creationId xmlns:a16="http://schemas.microsoft.com/office/drawing/2014/main" id="{8E4C6391-34C7-44A8-8EDE-AD17D022E0B9}"/>
+              </a:ext>
+            </a:extLst>
+          </p:cNvPr>
+          <p:cNvSpPr>
+            <a:spLocks xmlns:a="http://schemas.openxmlformats.org/drawingml/2006/main" noGrp="1"/>
+          </p:cNvSpPr>
+          <p:nvPr/>
+        </p:nvSpPr>
+        <p:spPr>
+          <a:xfrm xmlns:a="http://schemas.openxmlformats.org/drawingml/2006/main">
+            <a:off x="581025" y="4543425"/>
+            <a:ext cx="3714750" cy="323850"/>
           </a:xfrm>
           <a:prstGeom xmlns:a="http://schemas.openxmlformats.org/drawingml/2006/main" prst="rect">
             <a:avLst/>
@@ -7448,7 +7491,7 @@
           <a:lstStyle xmlns:a="http://schemas.openxmlformats.org/drawingml/2006/main"/>
           <a:p xmlns:a="http://schemas.openxmlformats.org/drawingml/2006/main">
             <a:pPr algn="l">
-              <a:defRPr sz="1875" b="1">
+              <a:defRPr sz="1725" b="1">
                 <a:solidFill>
                   <a:srgbClr val="0B0D0F"/>
                 </a:solidFill>
@@ -7465,80 +7508,80 @@
       </p:sp>
       <p:sp>
         <p:nvSpPr>
-          <p:cNvPr id="9" name="variable-k-interpretation">
-            <a:extLst xmlns:a="http://schemas.openxmlformats.org/drawingml/2006/main">
-              <a:ext uri="{FF2B5EF4-FFF2-40B4-BE49-F238E27FC236}">
-                <a16:creationId xmlns:a16="http://schemas.microsoft.com/office/drawing/2014/main" id="{B39AC4DE-EC68-48FB-8903-973DD551097F}"/>
-              </a:ext>
-            </a:extLst>
-          </p:cNvPr>
-          <p:cNvSpPr>
-            <a:spLocks xmlns:a="http://schemas.openxmlformats.org/drawingml/2006/main" noGrp="1"/>
-          </p:cNvSpPr>
-          <p:nvPr/>
-        </p:nvSpPr>
-        <p:spPr>
-          <a:xfrm xmlns:a="http://schemas.openxmlformats.org/drawingml/2006/main">
-            <a:off x="5219700" y="4305300"/>
-            <a:ext cx="6191250" cy="323850"/>
-          </a:xfrm>
-          <a:prstGeom xmlns:a="http://schemas.openxmlformats.org/drawingml/2006/main" prst="rect">
-            <a:avLst/>
-          </a:prstGeom>
-        </p:spPr>
-        <p:txBody>
-          <a:bodyPr xmlns:a="http://schemas.openxmlformats.org/drawingml/2006/main" wrap="square" lIns="0" tIns="0" rIns="0" bIns="0" anchor="t">
-            <a:noAutofit/>
-          </a:bodyPr>
-          <a:lstStyle xmlns:a="http://schemas.openxmlformats.org/drawingml/2006/main"/>
-          <a:p xmlns:a="http://schemas.openxmlformats.org/drawingml/2006/main">
-            <a:pPr algn="l">
-              <a:defRPr sz="1725" b="1">
-                <a:solidFill>
-                  <a:srgbClr val="0B0D0F"/>
-                </a:solidFill>
-                <a:latin typeface="Helvetica Neue"/>
-                <a:ea typeface="Helvetica Neue"/>
-                <a:cs typeface="Helvetica Neue"/>
-              </a:defRPr>
-            </a:pPr>
-            <a:r>
-              <a:t>Best utility: K=31, DFS=5.8968695574, penalty=0</a:t>
-            </a:r>
-          </a:p>
-        </p:txBody>
-      </p:sp>
-      <p:sp>
-        <p:nvSpPr>
-          <p:cNvPr id="10" name="variable-k-caveat">
-            <a:extLst xmlns:a="http://schemas.openxmlformats.org/drawingml/2006/main">
-              <a:ext uri="{FF2B5EF4-FFF2-40B4-BE49-F238E27FC236}">
-                <a16:creationId xmlns:a16="http://schemas.microsoft.com/office/drawing/2014/main" id="{928CAA5D-8413-4E31-B209-55E13E31DE25}"/>
-              </a:ext>
-            </a:extLst>
-          </p:cNvPr>
-          <p:cNvSpPr>
-            <a:spLocks xmlns:a="http://schemas.openxmlformats.org/drawingml/2006/main" noGrp="1"/>
-          </p:cNvSpPr>
-          <p:nvPr/>
-        </p:nvSpPr>
-        <p:spPr>
-          <a:xfrm xmlns:a="http://schemas.openxmlformats.org/drawingml/2006/main">
-            <a:off x="5219700" y="4676775"/>
-            <a:ext cx="6191250" cy="495300"/>
-          </a:xfrm>
-          <a:prstGeom xmlns:a="http://schemas.openxmlformats.org/drawingml/2006/main" prst="rect">
-            <a:avLst/>
-          </a:prstGeom>
-        </p:spPr>
-        <p:txBody>
-          <a:bodyPr xmlns:a="http://schemas.openxmlformats.org/drawingml/2006/main" wrap="square" lIns="0" tIns="0" rIns="0" bIns="0" anchor="t">
-            <a:noAutofit/>
-          </a:bodyPr>
-          <a:lstStyle xmlns:a="http://schemas.openxmlformats.org/drawingml/2006/main"/>
-          <a:p xmlns:a="http://schemas.openxmlformats.org/drawingml/2006/main">
-            <a:pPr algn="l">
-              <a:defRPr sz="1200" b="0">
+          <p:cNvPr id="10" name="schedule-label">
+            <a:extLst xmlns:a="http://schemas.openxmlformats.org/drawingml/2006/main">
+              <a:ext uri="{FF2B5EF4-FFF2-40B4-BE49-F238E27FC236}">
+                <a16:creationId xmlns:a16="http://schemas.microsoft.com/office/drawing/2014/main" id="{D0AD7F68-7827-4F60-BC44-FAB606430567}"/>
+              </a:ext>
+            </a:extLst>
+          </p:cNvPr>
+          <p:cNvSpPr>
+            <a:spLocks xmlns:a="http://schemas.openxmlformats.org/drawingml/2006/main" noGrp="1"/>
+          </p:cNvSpPr>
+          <p:nvPr/>
+        </p:nvSpPr>
+        <p:spPr>
+          <a:xfrm xmlns:a="http://schemas.openxmlformats.org/drawingml/2006/main">
+            <a:off x="4762500" y="4333875"/>
+            <a:ext cx="1714500" cy="209550"/>
+          </a:xfrm>
+          <a:prstGeom xmlns:a="http://schemas.openxmlformats.org/drawingml/2006/main" prst="rect">
+            <a:avLst/>
+          </a:prstGeom>
+        </p:spPr>
+        <p:txBody>
+          <a:bodyPr xmlns:a="http://schemas.openxmlformats.org/drawingml/2006/main" wrap="square" lIns="0" tIns="0" rIns="0" bIns="0" anchor="t">
+            <a:noAutofit/>
+          </a:bodyPr>
+          <a:lstStyle xmlns:a="http://schemas.openxmlformats.org/drawingml/2006/main"/>
+          <a:p xmlns:a="http://schemas.openxmlformats.org/drawingml/2006/main">
+            <a:pPr algn="l">
+              <a:defRPr sz="1125" b="1">
+                <a:solidFill>
+                  <a:srgbClr val="3D8DFF"/>
+                </a:solidFill>
+                <a:latin typeface="Helvetica Neue"/>
+                <a:ea typeface="Helvetica Neue"/>
+                <a:cs typeface="Helvetica Neue"/>
+              </a:defRPr>
+            </a:pPr>
+            <a:r>
+              <a:t>SCHEDULE</a:t>
+            </a:r>
+          </a:p>
+        </p:txBody>
+      </p:sp>
+      <p:sp>
+        <p:nvSpPr>
+          <p:cNvPr id="11" name="schedule-body">
+            <a:extLst xmlns:a="http://schemas.openxmlformats.org/drawingml/2006/main">
+              <a:ext uri="{FF2B5EF4-FFF2-40B4-BE49-F238E27FC236}">
+                <a16:creationId xmlns:a16="http://schemas.microsoft.com/office/drawing/2014/main" id="{C9C92D9A-1B97-4A16-9815-88B6737DCD35}"/>
+              </a:ext>
+            </a:extLst>
+          </p:cNvPr>
+          <p:cNvSpPr>
+            <a:spLocks xmlns:a="http://schemas.openxmlformats.org/drawingml/2006/main" noGrp="1"/>
+          </p:cNvSpPr>
+          <p:nvPr/>
+        </p:nvSpPr>
+        <p:spPr>
+          <a:xfrm xmlns:a="http://schemas.openxmlformats.org/drawingml/2006/main">
+            <a:off x="4762500" y="4629150"/>
+            <a:ext cx="3190875" cy="495300"/>
+          </a:xfrm>
+          <a:prstGeom xmlns:a="http://schemas.openxmlformats.org/drawingml/2006/main" prst="rect">
+            <a:avLst/>
+          </a:prstGeom>
+        </p:spPr>
+        <p:txBody>
+          <a:bodyPr xmlns:a="http://schemas.openxmlformats.org/drawingml/2006/main" wrap="square" lIns="0" tIns="0" rIns="0" bIns="0" anchor="t">
+            <a:noAutofit/>
+          </a:bodyPr>
+          <a:lstStyle xmlns:a="http://schemas.openxmlformats.org/drawingml/2006/main"/>
+          <a:p xmlns:a="http://schemas.openxmlformats.org/drawingml/2006/main">
+            <a:pPr algn="l">
+              <a:defRPr sz="1125" b="0">
                 <a:solidFill>
                   <a:srgbClr val="5E6670"/>
                 </a:solidFill>
@@ -7548,20 +7591,112 @@
               </a:defRPr>
             </a:pPr>
             <a:r>
-              <a:t>Start: K=24, DFS=5.8787660714. Final: K=21, DFS=5.8772821075. Same-seed λ response was non-monotone, so λ does not estimate K. GIF/trace retain persistent best DFS separately from best utility.</a:t>
+              <a:t>pilot 300 · median-loss acceptance 0.50→0.01
+hold 5% · final 20% (400 iterations) greedy</a:t>
+            </a:r>
+          </a:p>
+        </p:txBody>
+      </p:sp>
+      <p:sp>
+        <p:nvSpPr>
+          <p:cNvPr id="12" name="acceptance-label">
+            <a:extLst xmlns:a="http://schemas.openxmlformats.org/drawingml/2006/main">
+              <a:ext uri="{FF2B5EF4-FFF2-40B4-BE49-F238E27FC236}">
+                <a16:creationId xmlns:a16="http://schemas.microsoft.com/office/drawing/2014/main" id="{042B68DB-6570-4ECA-A9F9-EC93D8F0E68B}"/>
+              </a:ext>
+            </a:extLst>
+          </p:cNvPr>
+          <p:cNvSpPr>
+            <a:spLocks xmlns:a="http://schemas.openxmlformats.org/drawingml/2006/main" noGrp="1"/>
+          </p:cNvSpPr>
+          <p:nvPr/>
+        </p:nvSpPr>
+        <p:spPr>
+          <a:xfrm xmlns:a="http://schemas.openxmlformats.org/drawingml/2006/main">
+            <a:off x="8239125" y="4333875"/>
+            <a:ext cx="1714500" cy="209550"/>
+          </a:xfrm>
+          <a:prstGeom xmlns:a="http://schemas.openxmlformats.org/drawingml/2006/main" prst="rect">
+            <a:avLst/>
+          </a:prstGeom>
+        </p:spPr>
+        <p:txBody>
+          <a:bodyPr xmlns:a="http://schemas.openxmlformats.org/drawingml/2006/main" wrap="square" lIns="0" tIns="0" rIns="0" bIns="0" anchor="t">
+            <a:noAutofit/>
+          </a:bodyPr>
+          <a:lstStyle xmlns:a="http://schemas.openxmlformats.org/drawingml/2006/main"/>
+          <a:p xmlns:a="http://schemas.openxmlformats.org/drawingml/2006/main">
+            <a:pPr algn="l">
+              <a:defRPr sz="1125" b="1">
+                <a:solidFill>
+                  <a:srgbClr val="3D8DFF"/>
+                </a:solidFill>
+                <a:latin typeface="Helvetica Neue"/>
+                <a:ea typeface="Helvetica Neue"/>
+                <a:cs typeface="Helvetica Neue"/>
+              </a:defRPr>
+            </a:pPr>
+            <a:r>
+              <a:t>ACCEPTANCE</a:t>
+            </a:r>
+          </a:p>
+        </p:txBody>
+      </p:sp>
+      <p:sp>
+        <p:nvSpPr>
+          <p:cNvPr id="13" name="acceptance-body">
+            <a:extLst xmlns:a="http://schemas.openxmlformats.org/drawingml/2006/main">
+              <a:ext uri="{FF2B5EF4-FFF2-40B4-BE49-F238E27FC236}">
+                <a16:creationId xmlns:a16="http://schemas.microsoft.com/office/drawing/2014/main" id="{C238C8C0-3989-4F63-9604-3BB203578AA8}"/>
+              </a:ext>
+            </a:extLst>
+          </p:cNvPr>
+          <p:cNvSpPr>
+            <a:spLocks xmlns:a="http://schemas.openxmlformats.org/drawingml/2006/main" noGrp="1"/>
+          </p:cNvSpPr>
+          <p:nvPr/>
+        </p:nvSpPr>
+        <p:spPr>
+          <a:xfrm xmlns:a="http://schemas.openxmlformats.org/drawingml/2006/main">
+            <a:off x="8239125" y="4629150"/>
+            <a:ext cx="3562350" cy="495300"/>
+          </a:xfrm>
+          <a:prstGeom xmlns:a="http://schemas.openxmlformats.org/drawingml/2006/main" prst="rect">
+            <a:avLst/>
+          </a:prstGeom>
+        </p:spPr>
+        <p:txBody>
+          <a:bodyPr xmlns:a="http://schemas.openxmlformats.org/drawingml/2006/main" wrap="square" lIns="0" tIns="0" rIns="0" bIns="0" anchor="t">
+            <a:noAutofit/>
+          </a:bodyPr>
+          <a:lstStyle xmlns:a="http://schemas.openxmlformats.org/drawingml/2006/main"/>
+          <a:p xmlns:a="http://schemas.openxmlformats.org/drawingml/2006/main">
+            <a:pPr algn="l">
+              <a:defRPr sz="1125" b="0">
+                <a:solidFill>
+                  <a:srgbClr val="5E6670"/>
+                </a:solidFill>
+                <a:latin typeface="Helvetica Neue"/>
+                <a:ea typeface="Helvetica Neue"/>
+                <a:cs typeface="Helvetica Neue"/>
+              </a:defRPr>
+            </a:pPr>
+            <a:r>
+              <a:t>454 downhill (48.98%) · K visited 24–35
+loss median 3.34e−7 · p95 0.0300 · max 0.06727</a:t>
             </a:r>
           </a:p>
         </p:txBody>
       </p:sp>
       <p:cxnSp>
         <p:nvCxnSpPr>
-          <p:cNvPr id="28" name="week-error-rule"/>
+          <p:cNvPr id="32" name="run-note-rule"/>
           <p:cNvCxnSpPr/>
           <p:nvPr/>
         </p:nvCxnSpPr>
         <p:spPr>
           <a:xfrm xmlns:a="http://schemas.openxmlformats.org/drawingml/2006/main">
-            <a:off x="390525" y="5248275"/>
+            <a:off x="390525" y="5276850"/>
             <a:ext cx="11410950" cy="95"/>
           </a:xfrm>
           <a:prstGeom xmlns:a="http://schemas.openxmlformats.org/drawingml/2006/main" prst="straightConnector1">
@@ -7577,35 +7712,80 @@
       </p:cxnSp>
       <p:sp>
         <p:nvSpPr>
-          <p:cNvPr id="12" name="week-error-label">
-            <a:extLst xmlns:a="http://schemas.openxmlformats.org/drawingml/2006/main">
-              <a:ext uri="{FF2B5EF4-FFF2-40B4-BE49-F238E27FC236}">
-                <a16:creationId xmlns:a16="http://schemas.microsoft.com/office/drawing/2014/main" id="{BF38C1B3-5334-41FC-8767-244769790E11}"/>
-              </a:ext>
-            </a:extLst>
-          </p:cNvPr>
-          <p:cNvSpPr>
-            <a:spLocks xmlns:a="http://schemas.openxmlformats.org/drawingml/2006/main" noGrp="1"/>
-          </p:cNvSpPr>
-          <p:nvPr/>
-        </p:nvSpPr>
-        <p:spPr>
-          <a:xfrm xmlns:a="http://schemas.openxmlformats.org/drawingml/2006/main">
-            <a:off x="390525" y="5381625"/>
-            <a:ext cx="3238500" cy="209550"/>
-          </a:xfrm>
-          <a:prstGeom xmlns:a="http://schemas.openxmlformats.org/drawingml/2006/main" prst="rect">
-            <a:avLst/>
-          </a:prstGeom>
-        </p:spPr>
-        <p:txBody>
-          <a:bodyPr xmlns:a="http://schemas.openxmlformats.org/drawingml/2006/main" wrap="square" lIns="0" tIns="0" rIns="0" bIns="0" anchor="t">
-            <a:noAutofit/>
-          </a:bodyPr>
-          <a:lstStyle xmlns:a="http://schemas.openxmlformats.org/drawingml/2006/main"/>
-          <a:p xmlns:a="http://schemas.openxmlformats.org/drawingml/2006/main">
-            <a:pPr algn="l">
-              <a:defRPr sz="1125" b="1">
+          <p:cNvPr id="15" name="downhill-note">
+            <a:extLst xmlns:a="http://schemas.openxmlformats.org/drawingml/2006/main">
+              <a:ext uri="{FF2B5EF4-FFF2-40B4-BE49-F238E27FC236}">
+                <a16:creationId xmlns:a16="http://schemas.microsoft.com/office/drawing/2014/main" id="{3B288C7E-93F9-411C-AB55-7B3A678F2FCE}"/>
+              </a:ext>
+            </a:extLst>
+          </p:cNvPr>
+          <p:cNvSpPr>
+            <a:spLocks xmlns:a="http://schemas.openxmlformats.org/drawingml/2006/main" noGrp="1"/>
+          </p:cNvSpPr>
+          <p:nvPr/>
+        </p:nvSpPr>
+        <p:spPr>
+          <a:xfrm xmlns:a="http://schemas.openxmlformats.org/drawingml/2006/main">
+            <a:off x="390525" y="5438775"/>
+            <a:ext cx="11410950" cy="247650"/>
+          </a:xfrm>
+          <a:prstGeom xmlns:a="http://schemas.openxmlformats.org/drawingml/2006/main" prst="rect">
+            <a:avLst/>
+          </a:prstGeom>
+        </p:spPr>
+        <p:txBody>
+          <a:bodyPr xmlns:a="http://schemas.openxmlformats.org/drawingml/2006/main" wrap="square" lIns="0" tIns="0" rIns="0" bIns="0" anchor="t">
+            <a:noAutofit/>
+          </a:bodyPr>
+          <a:lstStyle xmlns:a="http://schemas.openxmlformats.org/drawingml/2006/main"/>
+          <a:p xmlns:a="http://schemas.openxmlformats.org/drawingml/2006/main">
+            <a:pPr algn="l">
+              <a:defRPr sz="1275" b="1">
+                <a:solidFill>
+                  <a:srgbClr val="0B0D0F"/>
+                </a:solidFill>
+                <a:latin typeface="Helvetica Neue"/>
+                <a:ea typeface="Helvetica Neue"/>
+                <a:cs typeface="Helvetica Neue"/>
+              </a:defRPr>
+            </a:pPr>
+            <a:r>
+              <a:t>Many accepted downhill moves were numerically tiny; the final 400 iterations were zero-temperature greedy polishing.</a:t>
+            </a:r>
+          </a:p>
+        </p:txBody>
+      </p:sp>
+      <p:sp>
+        <p:nvSpPr>
+          <p:cNvPr id="16" name="trace-error-note">
+            <a:extLst xmlns:a="http://schemas.openxmlformats.org/drawingml/2006/main">
+              <a:ext uri="{FF2B5EF4-FFF2-40B4-BE49-F238E27FC236}">
+                <a16:creationId xmlns:a16="http://schemas.microsoft.com/office/drawing/2014/main" id="{F4EDB140-729F-4784-B76C-41BAE386005A}"/>
+              </a:ext>
+            </a:extLst>
+          </p:cNvPr>
+          <p:cNvSpPr>
+            <a:spLocks xmlns:a="http://schemas.openxmlformats.org/drawingml/2006/main" noGrp="1"/>
+          </p:cNvSpPr>
+          <p:nvPr/>
+        </p:nvSpPr>
+        <p:spPr>
+          <a:xfrm xmlns:a="http://schemas.openxmlformats.org/drawingml/2006/main">
+            <a:off x="390525" y="5829300"/>
+            <a:ext cx="11410950" cy="285750"/>
+          </a:xfrm>
+          <a:prstGeom xmlns:a="http://schemas.openxmlformats.org/drawingml/2006/main" prst="rect">
+            <a:avLst/>
+          </a:prstGeom>
+        </p:spPr>
+        <p:txBody>
+          <a:bodyPr xmlns:a="http://schemas.openxmlformats.org/drawingml/2006/main" wrap="square" lIns="0" tIns="0" rIns="0" bIns="0" anchor="t">
+            <a:normAutofit fontScale="100000"/>
+          </a:bodyPr>
+          <a:lstStyle xmlns:a="http://schemas.openxmlformats.org/drawingml/2006/main"/>
+          <a:p xmlns:a="http://schemas.openxmlformats.org/drawingml/2006/main">
+            <a:pPr algn="l">
+              <a:defRPr sz="1050" b="0">
                 <a:solidFill>
                   <a:srgbClr val="5E6670"/>
                 </a:solidFill>
@@ -7615,152 +7795,17 @@
               </a:defRPr>
             </a:pPr>
             <a:r>
-              <a:t>SELECTED ERROR BENCHMARK</a:t>
-            </a:r>
-          </a:p>
-        </p:txBody>
-      </p:sp>
-      <p:sp>
-        <p:nvSpPr>
-          <p:cNvPr id="13" name="week-error-mhd">
-            <a:extLst xmlns:a="http://schemas.openxmlformats.org/drawingml/2006/main">
-              <a:ext uri="{FF2B5EF4-FFF2-40B4-BE49-F238E27FC236}">
-                <a16:creationId xmlns:a16="http://schemas.microsoft.com/office/drawing/2014/main" id="{ACEFCC7C-12D6-493C-99FF-384C6398C9E8}"/>
-              </a:ext>
-            </a:extLst>
-          </p:cNvPr>
-          <p:cNvSpPr>
-            <a:spLocks xmlns:a="http://schemas.openxmlformats.org/drawingml/2006/main" noGrp="1"/>
-          </p:cNvSpPr>
-          <p:nvPr/>
-        </p:nvSpPr>
-        <p:spPr>
-          <a:xfrm xmlns:a="http://schemas.openxmlformats.org/drawingml/2006/main">
-            <a:off x="390525" y="5657850"/>
-            <a:ext cx="3333750" cy="619125"/>
-          </a:xfrm>
-          <a:prstGeom xmlns:a="http://schemas.openxmlformats.org/drawingml/2006/main" prst="rect">
-            <a:avLst/>
-          </a:prstGeom>
-        </p:spPr>
-        <p:txBody>
-          <a:bodyPr xmlns:a="http://schemas.openxmlformats.org/drawingml/2006/main" wrap="square" lIns="0" tIns="0" rIns="0" bIns="0" anchor="t">
-            <a:noAutofit/>
-          </a:bodyPr>
-          <a:lstStyle xmlns:a="http://schemas.openxmlformats.org/drawingml/2006/main"/>
-          <a:p xmlns:a="http://schemas.openxmlformats.org/drawingml/2006/main">
-            <a:pPr algn="l">
-              <a:defRPr sz="1050" b="0">
-                <a:solidFill>
-                  <a:srgbClr val="5E6670"/>
-                </a:solidFill>
-                <a:latin typeface="Helvetica Neue"/>
-                <a:ea typeface="Helvetica Neue"/>
-                <a:cs typeface="Helvetica Neue"/>
-              </a:defRPr>
-            </a:pPr>
-            <a:r>
-              <a:t>MHD: repeatability combined with within-hour variability. Singleton hours retain zero variability because repeatability remains positive.</a:t>
-            </a:r>
-          </a:p>
-        </p:txBody>
-      </p:sp>
-      <p:sp>
-        <p:nvSpPr>
-          <p:cNvPr id="14" name="week-error-tac">
-            <a:extLst xmlns:a="http://schemas.openxmlformats.org/drawingml/2006/main">
-              <a:ext uri="{FF2B5EF4-FFF2-40B4-BE49-F238E27FC236}">
-                <a16:creationId xmlns:a16="http://schemas.microsoft.com/office/drawing/2014/main" id="{6A604397-AC2D-4FD0-82BE-39DD9575210A}"/>
-              </a:ext>
-            </a:extLst>
-          </p:cNvPr>
-          <p:cNvSpPr>
-            <a:spLocks xmlns:a="http://schemas.openxmlformats.org/drawingml/2006/main" noGrp="1"/>
-          </p:cNvSpPr>
-          <p:nvPr/>
-        </p:nvSpPr>
-        <p:spPr>
-          <a:xfrm xmlns:a="http://schemas.openxmlformats.org/drawingml/2006/main">
-            <a:off x="3990975" y="5657850"/>
-            <a:ext cx="2619375" cy="619125"/>
-          </a:xfrm>
-          <a:prstGeom xmlns:a="http://schemas.openxmlformats.org/drawingml/2006/main" prst="rect">
-            <a:avLst/>
-          </a:prstGeom>
-        </p:spPr>
-        <p:txBody>
-          <a:bodyPr xmlns:a="http://schemas.openxmlformats.org/drawingml/2006/main" wrap="square" lIns="0" tIns="0" rIns="0" bIns="0" anchor="t">
-            <a:noAutofit/>
-          </a:bodyPr>
-          <a:lstStyle xmlns:a="http://schemas.openxmlformats.org/drawingml/2006/main"/>
-          <a:p xmlns:a="http://schemas.openxmlformats.org/drawingml/2006/main">
-            <a:pPr algn="l">
-              <a:defRPr sz="1050" b="0">
-                <a:solidFill>
-                  <a:srgbClr val="5E6670"/>
-                </a:solidFill>
-                <a:latin typeface="Helvetica Neue"/>
-                <a:ea typeface="Helvetica Neue"/>
-                <a:cs typeface="Helvetica Neue"/>
-              </a:defRPr>
-            </a:pPr>
-            <a:r>
-              <a:t>TAC: pooled variability; zero pooled variability is replaced by the site median.</a:t>
-            </a:r>
-          </a:p>
-        </p:txBody>
-      </p:sp>
-      <p:sp>
-        <p:nvSpPr>
-          <p:cNvPr id="15" name="week-error-floor">
-            <a:extLst xmlns:a="http://schemas.openxmlformats.org/drawingml/2006/main">
-              <a:ext uri="{FF2B5EF4-FFF2-40B4-BE49-F238E27FC236}">
-                <a16:creationId xmlns:a16="http://schemas.microsoft.com/office/drawing/2014/main" id="{8A8124AE-ABD4-4384-A4A1-F295ED72C753}"/>
-              </a:ext>
-            </a:extLst>
-          </p:cNvPr>
-          <p:cNvSpPr>
-            <a:spLocks xmlns:a="http://schemas.openxmlformats.org/drawingml/2006/main" noGrp="1"/>
-          </p:cNvSpPr>
-          <p:nvPr/>
-        </p:nvSpPr>
-        <p:spPr>
-          <a:xfrm xmlns:a="http://schemas.openxmlformats.org/drawingml/2006/main">
-            <a:off x="6896100" y="5657850"/>
-            <a:ext cx="4905375" cy="619125"/>
-          </a:xfrm>
-          <a:prstGeom xmlns:a="http://schemas.openxmlformats.org/drawingml/2006/main" prst="rect">
-            <a:avLst/>
-          </a:prstGeom>
-        </p:spPr>
-        <p:txBody>
-          <a:bodyPr xmlns:a="http://schemas.openxmlformats.org/drawingml/2006/main" wrap="square" lIns="0" tIns="0" rIns="0" bIns="0" anchor="t">
-            <a:noAutofit/>
-          </a:bodyPr>
-          <a:lstStyle xmlns:a="http://schemas.openxmlformats.org/drawingml/2006/main"/>
-          <a:p xmlns:a="http://schemas.openxmlformats.org/drawingml/2006/main">
-            <a:pPr algn="l">
-              <a:defRPr sz="1050" b="0">
-                <a:solidFill>
-                  <a:srgbClr val="5E6670"/>
-                </a:solidFill>
-                <a:latin typeface="Helvetica Neue"/>
-                <a:ea typeface="Helvetica Neue"/>
-                <a:cs typeface="Helvetica Neue"/>
-              </a:defRPr>
-            </a:pPr>
-            <a:r>
-              <a:t>Floor selected for all rows: MHD 165/165, 43.210 ppb vs 1.485–26.063; TAC 168/168, 42.863 ppb vs 0.467–16.360. Hourly differences therefore do not affect R.</a:t>
-            </a:r>
-          </a:p>
-        </p:txBody>
-      </p:sp>
-      <p:sp>
-        <p:nvSpPr>
-          <p:cNvPr id="16" name="method-source">
-            <a:extLst xmlns:a="http://schemas.openxmlformats.org/drawingml/2006/main">
-              <a:ext uri="{FF2B5EF4-FFF2-40B4-BE49-F238E27FC236}">
-                <a16:creationId xmlns:a16="http://schemas.microsoft.com/office/drawing/2014/main" id="{DFA413FA-05E1-4953-8174-D7346BE42237}"/>
+              <a:t>GIF/trace: current and best penalized utility, K, and cellwise-I DFS (not bound). The selected floor defines R for all 333 rows; hourly error differences do not affect this run.</a:t>
+            </a:r>
+          </a:p>
+        </p:txBody>
+      </p:sp>
+      <p:sp>
+        <p:nvSpPr>
+          <p:cNvPr id="17" name="method-source">
+            <a:extLst xmlns:a="http://schemas.openxmlformats.org/drawingml/2006/main">
+              <a:ext uri="{FF2B5EF4-FFF2-40B4-BE49-F238E27FC236}">
+                <a16:creationId xmlns:a16="http://schemas.microsoft.com/office/drawing/2014/main" id="{36B3E671-C8ED-4BD3-834F-02DAA942A0E8}"/>
               </a:ext>
             </a:extLst>
           </p:cNvPr>
@@ -7802,10 +7847,10 @@
       </p:sp>
       <p:sp>
         <p:nvSpPr>
-          <p:cNvPr id="17" name="page-number">
-            <a:extLst xmlns:a="http://schemas.openxmlformats.org/drawingml/2006/main">
-              <a:ext uri="{FF2B5EF4-FFF2-40B4-BE49-F238E27FC236}">
-                <a16:creationId xmlns:a16="http://schemas.microsoft.com/office/drawing/2014/main" id="{ED79F3F7-5823-4709-A8E0-28956D3F2358}"/>
+          <p:cNvPr id="18" name="page-number">
+            <a:extLst xmlns:a="http://schemas.openxmlformats.org/drawingml/2006/main">
+              <a:ext uri="{FF2B5EF4-FFF2-40B4-BE49-F238E27FC236}">
+                <a16:creationId xmlns:a16="http://schemas.microsoft.com/office/drawing/2014/main" id="{A22FE767-D3CB-4E5A-AF02-462372938A4C}"/>
               </a:ext>
             </a:extLst>
           </p:cNvPr>
@@ -7848,7 +7893,7 @@
     </p:spTree>
     <p:extLst>
       <p:ext uri="{BB962C8B-B14F-4D97-AF65-F5344CB8AC3E}">
-        <p14:creationId xmlns:p14="http://schemas.microsoft.com/office/powerpoint/2010/main" val="218658239"/>
+        <p14:creationId xmlns:p14="http://schemas.microsoft.com/office/powerpoint/2010/main" val="1611759607"/>
       </p:ext>
     </p:extLst>
   </p:cSld>
@@ -7876,10 +7921,10 @@
       </p:grpSpPr>
       <p:sp>
         <p:nvSpPr>
-          <p:cNvPr id="13" name="slide-title">
-            <a:extLst xmlns:a="http://schemas.openxmlformats.org/drawingml/2006/main">
-              <a:ext uri="{FF2B5EF4-FFF2-40B4-BE49-F238E27FC236}">
-                <a16:creationId xmlns:a16="http://schemas.microsoft.com/office/drawing/2014/main" id="{F129EF34-6438-43D7-B0B1-03C551A030BC}"/>
+          <p:cNvPr id="14" name="slide-title">
+            <a:extLst xmlns:a="http://schemas.openxmlformats.org/drawingml/2006/main">
+              <a:ext uri="{FF2B5EF4-FFF2-40B4-BE49-F238E27FC236}">
+                <a16:creationId xmlns:a16="http://schemas.microsoft.com/office/drawing/2014/main" id="{E7811FD0-3082-4609-B2D2-D85B1DE799E6}"/>
               </a:ext>
             </a:extLst>
           </p:cNvPr>
@@ -7914,7 +7959,7 @@
               </a:defRPr>
             </a:pPr>
             <a:r>
-              <a:t>The covariance is deliberately provisional</a:t>
+              <a:t>Cellwise-I DFS uses an incomparable prior</a:t>
             </a:r>
           </a:p>
         </p:txBody>
@@ -7924,7 +7969,7 @@
           <p:cNvPr id="2" name="cov-current">
             <a:extLst xmlns:a="http://schemas.openxmlformats.org/drawingml/2006/main">
               <a:ext uri="{FF2B5EF4-FFF2-40B4-BE49-F238E27FC236}">
-                <a16:creationId xmlns:a16="http://schemas.microsoft.com/office/drawing/2014/main" id="{B9D2F1E8-670A-4E11-A2EF-CBA2158EABDE}"/>
+                <a16:creationId xmlns:a16="http://schemas.microsoft.com/office/drawing/2014/main" id="{0819D497-9B7B-47A5-B5D0-57F3491F30A2}"/>
               </a:ext>
             </a:extLst>
           </p:cNvPr>
@@ -7957,7 +8002,7 @@
           <p:cNvPr id="3" name="cov-target">
             <a:extLst xmlns:a="http://schemas.openxmlformats.org/drawingml/2006/main">
               <a:ext uri="{FF2B5EF4-FFF2-40B4-BE49-F238E27FC236}">
-                <a16:creationId xmlns:a16="http://schemas.microsoft.com/office/drawing/2014/main" id="{5DB04841-5BAE-403F-92D1-16A3D8DF13E9}"/>
+                <a16:creationId xmlns:a16="http://schemas.microsoft.com/office/drawing/2014/main" id="{A42A23C8-B239-4181-9970-13369584A957}"/>
               </a:ext>
             </a:extLst>
           </p:cNvPr>
@@ -7990,7 +8035,7 @@
           <p:cNvPr id="4" name="cov-current-label">
             <a:extLst xmlns:a="http://schemas.openxmlformats.org/drawingml/2006/main">
               <a:ext uri="{FF2B5EF4-FFF2-40B4-BE49-F238E27FC236}">
-                <a16:creationId xmlns:a16="http://schemas.microsoft.com/office/drawing/2014/main" id="{D63BD085-0ECE-42FB-87E7-0246FE44AAFF}"/>
+                <a16:creationId xmlns:a16="http://schemas.microsoft.com/office/drawing/2014/main" id="{4677464A-1722-4521-A966-BCA69575B73A}"/>
               </a:ext>
             </a:extLst>
           </p:cNvPr>
@@ -8002,7 +8047,7 @@
         <p:spPr>
           <a:xfrm xmlns:a="http://schemas.openxmlformats.org/drawingml/2006/main">
             <a:off x="695325" y="1752600"/>
-            <a:ext cx="2857500" cy="247650"/>
+            <a:ext cx="3429000" cy="247650"/>
           </a:xfrm>
           <a:prstGeom xmlns:a="http://schemas.openxmlformats.org/drawingml/2006/main" prst="rect">
             <a:avLst/>
@@ -8025,7 +8070,7 @@
               </a:defRPr>
             </a:pPr>
             <a:r>
-              <a:t>CURRENT BENCHMARK</a:t>
+              <a:t>CURRENT PROVISIONAL PRIOR</a:t>
             </a:r>
           </a:p>
         </p:txBody>
@@ -8035,7 +8080,7 @@
           <p:cNvPr id="5" name="cov-current-formula">
             <a:extLst xmlns:a="http://schemas.openxmlformats.org/drawingml/2006/main">
               <a:ext uri="{FF2B5EF4-FFF2-40B4-BE49-F238E27FC236}">
-                <a16:creationId xmlns:a16="http://schemas.microsoft.com/office/drawing/2014/main" id="{66722E4E-374C-4ED5-8466-EDF90C0FEAEA}"/>
+                <a16:creationId xmlns:a16="http://schemas.microsoft.com/office/drawing/2014/main" id="{2661538B-717D-476B-B372-B0E98A59E84F}"/>
               </a:ext>
             </a:extLst>
           </p:cNvPr>
@@ -8080,32 +8125,78 @@
           <p:cNvPr id="6" name="cov-current-body">
             <a:extLst xmlns:a="http://schemas.openxmlformats.org/drawingml/2006/main">
               <a:ext uri="{FF2B5EF4-FFF2-40B4-BE49-F238E27FC236}">
-                <a16:creationId xmlns:a16="http://schemas.microsoft.com/office/drawing/2014/main" id="{834CA7CF-B5C5-42DC-9CD8-67E1E116D088}"/>
-              </a:ext>
-            </a:extLst>
-          </p:cNvPr>
-          <p:cNvSpPr>
-            <a:spLocks xmlns:a="http://schemas.openxmlformats.org/drawingml/2006/main" noGrp="1"/>
-          </p:cNvSpPr>
-          <p:nvPr/>
-        </p:nvSpPr>
-        <p:spPr>
-          <a:xfrm xmlns:a="http://schemas.openxmlformats.org/drawingml/2006/main">
-            <a:off x="695325" y="3257550"/>
-            <a:ext cx="4286250" cy="781050"/>
-          </a:xfrm>
-          <a:prstGeom xmlns:a="http://schemas.openxmlformats.org/drawingml/2006/main" prst="rect">
-            <a:avLst/>
-          </a:prstGeom>
-        </p:spPr>
-        <p:txBody>
-          <a:bodyPr xmlns:a="http://schemas.openxmlformats.org/drawingml/2006/main" wrap="square" lIns="0" tIns="0" rIns="0" bIns="0" anchor="t">
-            <a:noAutofit/>
-          </a:bodyPr>
-          <a:lstStyle xmlns:a="http://schemas.openxmlformats.org/drawingml/2006/main"/>
-          <a:p xmlns:a="http://schemas.openxmlformats.org/drawingml/2006/main">
-            <a:pPr algn="l">
-              <a:defRPr sz="1725" b="0">
+                <a16:creationId xmlns:a16="http://schemas.microsoft.com/office/drawing/2014/main" id="{88620823-BBAD-4865-835B-ED39A73FBF53}"/>
+              </a:ext>
+            </a:extLst>
+          </p:cNvPr>
+          <p:cNvSpPr>
+            <a:spLocks xmlns:a="http://schemas.openxmlformats.org/drawingml/2006/main" noGrp="1"/>
+          </p:cNvSpPr>
+          <p:nvPr/>
+        </p:nvSpPr>
+        <p:spPr>
+          <a:xfrm xmlns:a="http://schemas.openxmlformats.org/drawingml/2006/main">
+            <a:off x="695325" y="3209925"/>
+            <a:ext cx="4286250" cy="657225"/>
+          </a:xfrm>
+          <a:prstGeom xmlns:a="http://schemas.openxmlformats.org/drawingml/2006/main" prst="rect">
+            <a:avLst/>
+          </a:prstGeom>
+        </p:spPr>
+        <p:txBody>
+          <a:bodyPr xmlns:a="http://schemas.openxmlformats.org/drawingml/2006/main" wrap="square" lIns="0" tIns="0" rIns="0" bIns="0" anchor="t">
+            <a:noAutofit/>
+          </a:bodyPr>
+          <a:lstStyle xmlns:a="http://schemas.openxmlformats.org/drawingml/2006/main"/>
+          <a:p xmlns:a="http://schemas.openxmlformats.org/drawingml/2006/main">
+            <a:pPr algn="l">
+              <a:defRPr sz="1575" b="1">
+                <a:solidFill>
+                  <a:srgbClr val="0B0D0F"/>
+                </a:solidFill>
+                <a:latin typeface="Helvetica Neue"/>
+                <a:ea typeface="Helvetica Neue"/>
+                <a:cs typeface="Helvetica Neue"/>
+              </a:defRPr>
+            </a:pPr>
+            <a:r>
+              <a:t>reduced regions K=25     DFS 5.9260
+cellwise-I K=1,813     DFS 4.9420</a:t>
+            </a:r>
+          </a:p>
+        </p:txBody>
+      </p:sp>
+      <p:sp>
+        <p:nvSpPr>
+          <p:cNvPr id="7" name="cov-current-note">
+            <a:extLst xmlns:a="http://schemas.openxmlformats.org/drawingml/2006/main">
+              <a:ext uri="{FF2B5EF4-FFF2-40B4-BE49-F238E27FC236}">
+                <a16:creationId xmlns:a16="http://schemas.microsoft.com/office/drawing/2014/main" id="{ABEB2773-A8B1-4B03-A379-3461F299CD76}"/>
+              </a:ext>
+            </a:extLst>
+          </p:cNvPr>
+          <p:cNvSpPr>
+            <a:spLocks xmlns:a="http://schemas.openxmlformats.org/drawingml/2006/main" noGrp="1"/>
+          </p:cNvSpPr>
+          <p:nvPr/>
+        </p:nvSpPr>
+        <p:spPr>
+          <a:xfrm xmlns:a="http://schemas.openxmlformats.org/drawingml/2006/main">
+            <a:off x="695325" y="3914775"/>
+            <a:ext cx="4286250" cy="457200"/>
+          </a:xfrm>
+          <a:prstGeom xmlns:a="http://schemas.openxmlformats.org/drawingml/2006/main" prst="rect">
+            <a:avLst/>
+          </a:prstGeom>
+        </p:spPr>
+        <p:txBody>
+          <a:bodyPr xmlns:a="http://schemas.openxmlformats.org/drawingml/2006/main" wrap="square" lIns="0" tIns="0" rIns="0" bIns="0" anchor="t">
+            <a:noAutofit/>
+          </a:bodyPr>
+          <a:lstStyle xmlns:a="http://schemas.openxmlformats.org/drawingml/2006/main"/>
+          <a:p xmlns:a="http://schemas.openxmlformats.org/drawingml/2006/main">
+            <a:pPr algn="l">
+              <a:defRPr sz="1350" b="0">
                 <a:solidFill>
                   <a:srgbClr val="5E6670"/>
                 </a:solidFill>
@@ -8115,17 +8206,18 @@
               </a:defRPr>
             </a:pPr>
             <a:r>
-              <a:t>The same isotropic regional covariance is used for every partition.</a:t>
-            </a:r>
-          </a:p>
-        </p:txBody>
-      </p:sp>
-      <p:sp>
-        <p:nvSpPr>
-          <p:cNvPr id="7" name="cov-target-label">
-            <a:extLst xmlns:a="http://schemas.openxmlformats.org/drawingml/2006/main">
-              <a:ext uri="{FF2B5EF4-FFF2-40B4-BE49-F238E27FC236}">
-                <a16:creationId xmlns:a16="http://schemas.microsoft.com/office/drawing/2014/main" id="{D69AB0F8-86B9-4389-B757-3922BB4C23FF}"/>
+              <a:t>Reduced: τ²I per region + summed columns.
+Cellwise-I: independent τ²I per cell.</a:t>
+            </a:r>
+          </a:p>
+        </p:txBody>
+      </p:sp>
+      <p:sp>
+        <p:nvSpPr>
+          <p:cNvPr id="8" name="cov-target-label">
+            <a:extLst xmlns:a="http://schemas.openxmlformats.org/drawingml/2006/main">
+              <a:ext uri="{FF2B5EF4-FFF2-40B4-BE49-F238E27FC236}">
+                <a16:creationId xmlns:a16="http://schemas.microsoft.com/office/drawing/2014/main" id="{18A50258-DEE5-42A1-A534-06AE71A531BA}"/>
               </a:ext>
             </a:extLst>
           </p:cNvPr>
@@ -8167,10 +8259,10 @@
       </p:sp>
       <p:sp>
         <p:nvSpPr>
-          <p:cNvPr id="8" name="cov-target-formula">
-            <a:extLst xmlns:a="http://schemas.openxmlformats.org/drawingml/2006/main">
-              <a:ext uri="{FF2B5EF4-FFF2-40B4-BE49-F238E27FC236}">
-                <a16:creationId xmlns:a16="http://schemas.microsoft.com/office/drawing/2014/main" id="{8F6AA392-E240-4EF0-9D95-5949817D4BE9}"/>
+          <p:cNvPr id="9" name="cov-target-formula">
+            <a:extLst xmlns:a="http://schemas.openxmlformats.org/drawingml/2006/main">
+              <a:ext uri="{FF2B5EF4-FFF2-40B4-BE49-F238E27FC236}">
+                <a16:creationId xmlns:a16="http://schemas.microsoft.com/office/drawing/2014/main" id="{1BC906F4-F088-4DE8-AE00-2C9A1FAC386B}"/>
               </a:ext>
             </a:extLst>
           </p:cNvPr>
@@ -8212,10 +8304,10 @@
       </p:sp>
       <p:sp>
         <p:nvSpPr>
-          <p:cNvPr id="9" name="cov-target-body">
-            <a:extLst xmlns:a="http://schemas.openxmlformats.org/drawingml/2006/main">
-              <a:ext uri="{FF2B5EF4-FFF2-40B4-BE49-F238E27FC236}">
-                <a16:creationId xmlns:a16="http://schemas.microsoft.com/office/drawing/2014/main" id="{3874F028-E99C-466C-92B7-4A5B1777B65F}"/>
+          <p:cNvPr id="10" name="cov-target-body">
+            <a:extLst xmlns:a="http://schemas.openxmlformats.org/drawingml/2006/main">
+              <a:ext uri="{FF2B5EF4-FFF2-40B4-BE49-F238E27FC236}">
+                <a16:creationId xmlns:a16="http://schemas.microsoft.com/office/drawing/2014/main" id="{7E350BB2-5D28-481E-8046-C19A1476DB2A}"/>
               </a:ext>
             </a:extLst>
           </p:cNvPr>
@@ -8250,17 +8342,17 @@
               </a:defRPr>
             </a:pPr>
             <a:r>
-              <a:t>Start from fine-grid covariance B and project it for each partition.</a:t>
-            </a:r>
-          </a:p>
-        </p:txBody>
-      </p:sp>
-      <p:sp>
-        <p:nvSpPr>
-          <p:cNvPr id="10" name="cov-conclusion">
-            <a:extLst xmlns:a="http://schemas.openxmlformats.org/drawingml/2006/main">
-              <a:ext uri="{FF2B5EF4-FFF2-40B4-BE49-F238E27FC236}">
-                <a16:creationId xmlns:a16="http://schemas.microsoft.com/office/drawing/2014/main" id="{075D2238-48B8-49A9-B249-DC4D196413FE}"/>
+              <a:t>Project fine-grid covariance B with consistent prolongation and normalization.</a:t>
+            </a:r>
+          </a:p>
+        </p:txBody>
+      </p:sp>
+      <p:sp>
+        <p:nvSpPr>
+          <p:cNvPr id="11" name="cov-conclusion">
+            <a:extLst xmlns:a="http://schemas.openxmlformats.org/drawingml/2006/main">
+              <a:ext uri="{FF2B5EF4-FFF2-40B4-BE49-F238E27FC236}">
+                <a16:creationId xmlns:a16="http://schemas.microsoft.com/office/drawing/2014/main" id="{9ADABBA1-65AA-4761-8880-888B9D82B945}"/>
               </a:ext>
             </a:extLst>
           </p:cNvPr>
@@ -8295,17 +8387,17 @@
               </a:defRPr>
             </a:pPr>
             <a:r>
-              <a:t>Reusing one numerical Bₚ breaks the Bocquet transformation assumption. The code already accepts a partition-dependent covariance builder, so the search machinery need not change.</a:t>
-            </a:r>
-          </a:p>
-        </p:txBody>
-      </p:sp>
-      <p:sp>
-        <p:nvSpPr>
-          <p:cNvPr id="11" name="method-source">
-            <a:extLst xmlns:a="http://schemas.openxmlformats.org/drawingml/2006/main">
-              <a:ext uri="{FF2B5EF4-FFF2-40B4-BE49-F238E27FC236}">
-                <a16:creationId xmlns:a16="http://schemas.microsoft.com/office/drawing/2014/main" id="{09666D65-1F11-4C1A-86C2-97D961123B99}"/>
+              <a:t>Reduced signal covariance contains cross-cell terms, so 4.942 is neither a bound nor a maximum. Bₚ=PBPᵀ plus consistent projection, prolongation, and normalization are required before a meaningful no-reduction upper reference exists.</a:t>
+            </a:r>
+          </a:p>
+        </p:txBody>
+      </p:sp>
+      <p:sp>
+        <p:nvSpPr>
+          <p:cNvPr id="12" name="method-source">
+            <a:extLst xmlns:a="http://schemas.openxmlformats.org/drawingml/2006/main">
+              <a:ext uri="{FF2B5EF4-FFF2-40B4-BE49-F238E27FC236}">
+                <a16:creationId xmlns:a16="http://schemas.microsoft.com/office/drawing/2014/main" id="{7CB04E36-D7CB-482F-833A-2E7ADE0BC05B}"/>
               </a:ext>
             </a:extLst>
           </p:cNvPr>
@@ -8340,17 +8432,17 @@
               </a:defRPr>
             </a:pPr>
             <a:r>
-              <a:t>Method: objectives.py; covariance design inspired by Bocquet, Wu &amp; Chevallier.</a:t>
-            </a:r>
-          </a:p>
-        </p:txBody>
-      </p:sp>
-      <p:sp>
-        <p:nvSpPr>
-          <p:cNvPr id="12" name="page-number">
-            <a:extLst xmlns:a="http://schemas.openxmlformats.org/drawingml/2006/main">
-              <a:ext uri="{FF2B5EF4-FFF2-40B4-BE49-F238E27FC236}">
-                <a16:creationId xmlns:a16="http://schemas.microsoft.com/office/drawing/2014/main" id="{488A7F7E-E550-44B8-8C89-2ED4C8AD3FBF}"/>
+              <a:t>Source: full-week manifest; covariance design inspired by Bocquet, Wu &amp; Chevallier.</a:t>
+            </a:r>
+          </a:p>
+        </p:txBody>
+      </p:sp>
+      <p:sp>
+        <p:nvSpPr>
+          <p:cNvPr id="13" name="page-number">
+            <a:extLst xmlns:a="http://schemas.openxmlformats.org/drawingml/2006/main">
+              <a:ext uri="{FF2B5EF4-FFF2-40B4-BE49-F238E27FC236}">
+                <a16:creationId xmlns:a16="http://schemas.microsoft.com/office/drawing/2014/main" id="{C60D06DC-1509-4621-AC2A-1F9FC7D4AA4F}"/>
               </a:ext>
             </a:extLst>
           </p:cNvPr>
@@ -8393,7 +8485,7 @@
     </p:spTree>
     <p:extLst>
       <p:ext uri="{BB962C8B-B14F-4D97-AF65-F5344CB8AC3E}">
-        <p14:creationId xmlns:p14="http://schemas.microsoft.com/office/powerpoint/2010/main" val="451059008"/>
+        <p14:creationId xmlns:p14="http://schemas.microsoft.com/office/powerpoint/2010/main" val="2050666115"/>
       </p:ext>
     </p:extLst>
   </p:cSld>

</xml_diff>